<commit_message>
refine: unify room commerce visuals and reviewed mobile interactions
</commit_message>
<xml_diff>
--- a/docs/presentation/GScene_Final_52g.pptx
+++ b/docs/presentation/GScene_Final_52g.pptx
@@ -2,17 +2,17 @@
 <file path=ppt/presentation.xml><?xml version="1.0" encoding="utf-8"?>
 <p:presentation xmlns:p="http://schemas.openxmlformats.org/presentationml/2006/main">
   <p:sldMasterIdLst>
-    <p:sldMasterId xmlns:r="http://schemas.openxmlformats.org/officeDocument/2006/relationships" id="2147483648" r:id="R78817fa7451546d4"/>
+    <p:sldMasterId xmlns:r="http://schemas.openxmlformats.org/officeDocument/2006/relationships" id="2147483648" r:id="Rf89e0dd3f5424699"/>
   </p:sldMasterIdLst>
   <p:notesMasterIdLst>
-    <p:notesMasterId xmlns:r="http://schemas.openxmlformats.org/officeDocument/2006/relationships" r:id="Rf81136d8d96a434f"/>
+    <p:notesMasterId xmlns:r="http://schemas.openxmlformats.org/officeDocument/2006/relationships" r:id="R86f70b1d939b4cde"/>
   </p:notesMasterIdLst>
   <p:sldIdLst>
-    <p:sldId xmlns:r="http://schemas.openxmlformats.org/officeDocument/2006/relationships" id="256" r:id="Rcd9f5941cb25432b"/>
-    <p:sldId xmlns:r="http://schemas.openxmlformats.org/officeDocument/2006/relationships" id="257" r:id="R15779409f11643ed"/>
-    <p:sldId xmlns:r="http://schemas.openxmlformats.org/officeDocument/2006/relationships" id="258" r:id="R3197f584361a44db"/>
-    <p:sldId xmlns:r="http://schemas.openxmlformats.org/officeDocument/2006/relationships" id="259" r:id="R65af193d02ac48cb"/>
-    <p:sldId xmlns:r="http://schemas.openxmlformats.org/officeDocument/2006/relationships" id="260" r:id="Re860f7882d0e4cba"/>
+    <p:sldId xmlns:r="http://schemas.openxmlformats.org/officeDocument/2006/relationships" id="256" r:id="R407fff5adce84caa"/>
+    <p:sldId xmlns:r="http://schemas.openxmlformats.org/officeDocument/2006/relationships" id="257" r:id="Rb6670561e8424f22"/>
+    <p:sldId xmlns:r="http://schemas.openxmlformats.org/officeDocument/2006/relationships" id="258" r:id="Raec0db427ad64ca8"/>
+    <p:sldId xmlns:r="http://schemas.openxmlformats.org/officeDocument/2006/relationships" id="259" r:id="R4d3d4439ee164c69"/>
+    <p:sldId xmlns:r="http://schemas.openxmlformats.org/officeDocument/2006/relationships" id="260" r:id="R626d78d2db2b40f7"/>
   </p:sldIdLst>
   <p:sldSz cx="12192000" cy="6858000"/>
   <p:notesSz cx="6858000" cy="9144000"/>
@@ -446,12 +446,12 @@
           <a:lstStyle xmlns:a="http://schemas.openxmlformats.org/drawingml/2006/main"/>
           <a:p xmlns:a="http://schemas.openxmlformats.org/drawingml/2006/main">
             <a:r>
-              <a:t>Sources: docs/ideas/doc03_final_ideation.md; docs/criterion/crit00_proj_guide.md; docs/design/room_commerce_contract.md; docs/design/release_verification.md; docs/logs/nightly_2026-09-21.md. All are repository-supplied sources, not external research.</a:t>
-            </a:r>
-          </a:p>
-          <a:p xmlns:a="http://schemas.openxmlformats.org/drawingml/2006/main">
-            <a:r>
-              <a:t>문제 정의는 기획의 가설이다. 인터뷰 원문, 고객 조사 결과, 전환 성과를 인용하지 않는다. 2030 고객이 상품을 자신의 생활과 연결해 상상하기 어렵다는 문제에서 출발한다.</a:t>
+              <a:t>Sources: docs/ideas/doc03_final_ideation.md; docs/criterion/crit00_proj_guide.md; docs/criterion/crit02_overnight_quality_loop.md; docs/design/room_commerce_contract.md; docs/design/release_verification.md. Repository sources. No external research or customer outcome evidence.</a:t>
+            </a:r>
+          </a:p>
+          <a:p xmlns:a="http://schemas.openxmlformats.org/drawingml/2006/main">
+            <a:r>
+              <a:t>CLAIM: 상품을 생활로 연결하는 해석 부담을 줄일 입구가 필요하다는 문제 가설. WHY: 상품 정보와 자기 사용 장면의 연결은 고객의 몫이다. EVIDENCE: doc03 product problem framing, not a customer study. SO WHAT: 탐색을 고객의 생활 질문에서 시작한다.</a:t>
             </a:r>
           </a:p>
         </p:txBody>
@@ -521,12 +521,12 @@
           <a:lstStyle xmlns:a="http://schemas.openxmlformats.org/drawingml/2006/main"/>
           <a:p xmlns:a="http://schemas.openxmlformats.org/drawingml/2006/main">
             <a:r>
-              <a:t>Sources: docs/ideas/doc03_final_ideation.md; docs/criterion/crit00_proj_guide.md; docs/design/room_commerce_contract.md; docs/design/release_verification.md; docs/logs/nightly_2026-09-21.md. All are repository-supplied sources, not external research.</a:t>
-            </a:r>
-          </a:p>
-          <a:p xmlns:a="http://schemas.openxmlformats.org/drawingml/2006/main">
-            <a:r>
-              <a:t>보유한 상품이 놓이는 생활 공간을 다음 쇼핑의 출발점으로 삼는 제품 방향. Screenshot: outputs/release-qa/living-320-public.png, actual rendered prototype before overnight polish. The room artwork is illustrative, not a product photograph or virtual fitting.</a:t>
+              <a:t>Sources: docs/ideas/doc03_final_ideation.md; docs/criterion/crit00_proj_guide.md; docs/criterion/crit02_overnight_quality_loop.md; docs/design/room_commerce_contract.md; docs/design/release_verification.md. Repository sources. No external research or customer outcome evidence.</a:t>
+            </a:r>
+          </a:p>
+          <a:p xmlns:a="http://schemas.openxmlformats.org/drawingml/2006/main">
+            <a:r>
+              <a:t>CLAIM: 보유 물건이 있는 개인 공간에서 쇼핑의 이유를 시작한다. WHY: 이미 가진 물건은 새 상품이 쓰일 장면의 구체적인 기준이 된다. EVIDENCE: Actual prototype room screenshot: outputs/quality-20260922/cycle1/revised/01-room-idle-390.png, local production mode after shared-garment/navigation/UI fixes. SO WHAT: 소유 맥락이 생활 질문을 여는 commerce entry가 될 수 있다는 design hypothesis. 가상 고객 구매, 일반화한 공간 그림이며 상품의 정확한 외형이나 가상 피팅이 아니다.</a:t>
             </a:r>
           </a:p>
         </p:txBody>
@@ -596,12 +596,12 @@
           <a:lstStyle xmlns:a="http://schemas.openxmlformats.org/drawingml/2006/main"/>
           <a:p xmlns:a="http://schemas.openxmlformats.org/drawingml/2006/main">
             <a:r>
-              <a:t>Sources: docs/ideas/doc03_final_ideation.md; docs/criterion/crit00_proj_guide.md; docs/design/room_commerce_contract.md; docs/design/release_verification.md; docs/logs/nightly_2026-09-21.md. All are repository-supplied sources, not external research.</a:t>
-            </a:r>
-          </a:p>
-          <a:p xmlns:a="http://schemas.openxmlformats.org/drawingml/2006/main">
-            <a:r>
-              <a:t>Screenshot: outputs/nightly-qa/integrated/room-applied-shirt-390.png, actual integrated prototype captured during Main QA. 가상 고객의 실상품 카탈로그 연결 구매 물건을 공간에 표시한다. Figure crop retains Fashion/Food/Living/Beauty labels. Actual purchase ownership is fictional; character art is a generalized illustration.</a:t>
+              <a:t>Sources: docs/ideas/doc03_final_ideation.md; docs/criterion/crit00_proj_guide.md; docs/criterion/crit02_overnight_quality_loop.md; docs/design/room_commerce_contract.md; docs/design/release_verification.md. Repository sources. No external research or customer outcome evidence.</a:t>
+            </a:r>
+          </a:p>
+          <a:p xmlns:a="http://schemas.openxmlformats.org/drawingml/2006/main">
+            <a:r>
+              <a:t>CLAIM: GS SHOP의 기존 상품 자산을 생활 이유로 만나는 탐색 입구. WHY: 보유 물건에 상황과 예산을 더하면 상품을 고를 이유를 구체화할 수 있다. EVIDENCE: actual post-fix Fashion UI. Main selected owned cream knit as anchor, then 출근 + 50,000원 이하, then viewed example product reasons. Screenshot deck-fashion-reasons-390.png visibly shows the selected condition, fictional sample disclosure, 39,000원 charcoal trousers and the cream-knit reason. The on-slide quote reproduces that exact prototype reason, not a customer interview. Separate Main Scene sheet does not auto-forward to Fashion; no such link is asserted. SO WHAT: existing catalog/supply/recommendation assets can be connected to personal living context. Existing GS SHOP API/learning recommender integration not claimed. Recommendations are fictional examples.</a:t>
             </a:r>
           </a:p>
         </p:txBody>
@@ -671,12 +671,12 @@
           <a:lstStyle xmlns:a="http://schemas.openxmlformats.org/drawingml/2006/main"/>
           <a:p xmlns:a="http://schemas.openxmlformats.org/drawingml/2006/main">
             <a:r>
-              <a:t>Sources: docs/ideas/doc03_final_ideation.md; docs/criterion/crit00_proj_guide.md; docs/design/room_commerce_contract.md; docs/design/release_verification.md; docs/logs/nightly_2026-09-21.md. All are repository-supplied sources, not external research.</a:t>
-            </a:r>
-          </a:p>
-          <a:p xmlns:a="http://schemas.openxmlformats.org/drawingml/2006/main">
-            <a:r>
-              <a:t>Actual consecutive integrated scenario from Main QA: same fictional user 민서 and avatar M01, initial knit product 1106041553, supported owned shirt product 1083830467. wardrobe-open-390.png shows engaged browsing; fashion-apply-390.png shows completed temporary shirt preview plus explicit apply CTA; room-applied-shirt-390.png shows returned character with the same confirmed shirt ID. Main verified first rapid taps stayed in room, ready second tap navigated to Fashion, explicit apply preserved identity on return. Screenshots: outputs/nightly-qa/integrated/. Image crops only; no UI or character resynthesis. These are functional observations, not customer-outcome validation.</a:t>
+              <a:t>Sources: docs/ideas/doc03_final_ideation.md; docs/criterion/crit00_proj_guide.md; docs/criterion/crit02_overnight_quality_loop.md; docs/design/room_commerce_contract.md; docs/design/release_verification.md. Repository sources. No external research or customer outcome evidence.</a:t>
+            </a:r>
+          </a:p>
+          <a:p xmlns:a="http://schemas.openxmlformats.org/drawingml/2006/main">
+            <a:r>
+              <a:t>CLAIM: 동일 구매 상품과 확정 상태의 연속성은 개인 공간의 기반이다. WHY: 화면마다 상품이 달라지거나 선택이 사라지면 나의 공간이라는 약속이 깨진다. EVIDENCE: same fictional user M01, knit 1106041553 before and shirt 1083830467 after explicit apply; actual consecutive post-fix local production captures outputs/quality-20260922/cycle1/revised/06-wardrobe-open-390.png, 09-outfit-preview-390.png, 11-room-after-apply-390.png and 11b-room-after-reload-390.png. These captures show one M01 avatar, initial cream knit 1106041553 and explicitly applied blue shirt 1083830467. Main verified the actions and Visual Critic passed the updated shared garment identity. SO WHAT: living interaction and catalog navigation share product identity and state. Owned apply evidence only; not a new purchase/conversion proof.</a:t>
             </a:r>
           </a:p>
         </p:txBody>
@@ -746,12 +746,12 @@
           <a:lstStyle xmlns:a="http://schemas.openxmlformats.org/drawingml/2006/main"/>
           <a:p xmlns:a="http://schemas.openxmlformats.org/drawingml/2006/main">
             <a:r>
-              <a:t>Sources: docs/ideas/doc03_final_ideation.md; docs/criterion/crit00_proj_guide.md; docs/design/room_commerce_contract.md; docs/design/release_verification.md; docs/logs/nightly_2026-09-21.md. All are repository-supplied sources, not external research.</a:t>
-            </a:r>
-          </a:p>
-          <a:p xmlns:a="http://schemas.openxmlformats.org/drawingml/2006/main">
-            <a:r>
-              <a:t>Product significance is a hypothesis, not validated business impact. Agent execution is evidenced by the documented split between builders and visual QA, review/fix/retest records, and release checks. No claim of customer validation, uplift, automation percentage, speed comparison, or unsupported outcomes.</a:t>
+              <a:t>Sources: docs/ideas/doc03_final_ideation.md; docs/criterion/crit00_proj_guide.md; docs/criterion/crit02_overnight_quality_loop.md; docs/design/room_commerce_contract.md; docs/design/release_verification.md. Repository sources. No external research or customer outcome evidence.</a:t>
+            </a:r>
+          </a:p>
+          <a:p xmlns:a="http://schemas.openxmlformats.org/drawingml/2006/main">
+            <a:r>
+              <a:t>CLAIM: GS SHOP의 기존 상품을 개인의 생활 질문에서 만나는 interface ambition. WHY: 고객이 원하는 생활을 먼저 떠올릴 수 있으면 상품이 필요한 이유를 찾는 탐색을 시험할 수 있다. EVIDENCE: work/quality/cycle1-critic.md identified inconsistent room/Fashion garment silhouettes; Builder created a shared canonical garment presentation; Main and Visual Critic inspected the actual same-item screens and confirmed identity. Slide 4 shows the post-fix continuous state proof. SO WHAT: test whether users can explain personal relevance, without asserting validated effect or conversion uplift.</a:t>
             </a:r>
           </a:p>
         </p:txBody>
@@ -819,7 +819,7 @@
   </p:cSld>
   <p:clrMap bg1="lt1" tx1="dk1" bg2="lt2" tx2="dk2" accent1="accent1" accent2="accent2" accent3="accent3" accent4="accent4" accent5="accent5" accent6="accent6" hlink="hlink" folHlink="folHlink"/>
   <p:sldLayoutIdLst>
-    <p:sldLayoutId xmlns:r="http://schemas.openxmlformats.org/officeDocument/2006/relationships" id="2147483649" r:id="R91bf803209764924"/>
+    <p:sldLayoutId xmlns:r="http://schemas.openxmlformats.org/officeDocument/2006/relationships" id="2147483649" r:id="R67587582a68d43b8"/>
   </p:sldLayoutIdLst>
   <p:txStyles>
     <p:titleStyle>
@@ -1367,10 +1367,10 @@
       </p:grpSpPr>
       <p:sp>
         <p:nvSpPr>
-          <p:cNvPr id="5" name="brand">
+          <p:cNvPr id="6" name="brand">
             <a:extLst xmlns:a="http://schemas.openxmlformats.org/drawingml/2006/main">
               <a:ext uri="{FF2B5EF4-FFF2-40B4-BE49-F238E27FC236}">
-                <a16:creationId xmlns:a16="http://schemas.microsoft.com/office/drawing/2014/main" id="{DCCC8D51-FE2C-4C39-AB04-FBC84E3A842C}"/>
+                <a16:creationId xmlns:a16="http://schemas.microsoft.com/office/drawing/2014/main" id="{6220D1F7-B7C6-4E91-95A7-5B2D50A6B4E9}"/>
               </a:ext>
             </a:extLst>
           </p:cNvPr>
@@ -1381,8 +1381,8 @@
         </p:nvSpPr>
         <p:spPr>
           <a:xfrm xmlns:a="http://schemas.openxmlformats.org/drawingml/2006/main">
-            <a:off x="666750" y="438150"/>
-            <a:ext cx="3810000" cy="523875"/>
+            <a:off x="666750" y="400050"/>
+            <a:ext cx="5524500" cy="552450"/>
           </a:xfrm>
           <a:prstGeom xmlns:a="http://schemas.openxmlformats.org/drawingml/2006/main" prst="rect">
             <a:avLst/>
@@ -1399,7 +1399,7 @@
           <a:lstStyle xmlns:a="http://schemas.openxmlformats.org/drawingml/2006/main"/>
           <a:p xmlns:a="http://schemas.openxmlformats.org/drawingml/2006/main">
             <a:pPr>
-              <a:defRPr sz="2550" b="1">
+              <a:defRPr sz="2700" b="1">
                 <a:solidFill>
                   <a:srgbClr val="F5F3EB"/>
                 </a:solidFill>
@@ -1409,7 +1409,7 @@
               </a:defRPr>
             </a:pPr>
             <a:r>
-              <a:rPr sz="2550" b="1">
+              <a:rPr sz="2700" b="1">
                 <a:solidFill>
                   <a:srgbClr val="F5F3EB"/>
                 </a:solidFill>
@@ -1424,10 +1424,10 @@
       </p:sp>
       <p:sp>
         <p:nvSpPr>
-          <p:cNvPr id="2" name="problem-headline">
+          <p:cNvPr id="2" name="title">
             <a:extLst xmlns:a="http://schemas.openxmlformats.org/drawingml/2006/main">
               <a:ext uri="{FF2B5EF4-FFF2-40B4-BE49-F238E27FC236}">
-                <a16:creationId xmlns:a16="http://schemas.microsoft.com/office/drawing/2014/main" id="{277070AF-2BC5-4C86-B9B4-D5D2A718E700}"/>
+                <a16:creationId xmlns:a16="http://schemas.microsoft.com/office/drawing/2014/main" id="{D86D580B-ED83-4B8F-9020-CE94FF845177}"/>
               </a:ext>
             </a:extLst>
           </p:cNvPr>
@@ -1438,8 +1438,8 @@
         </p:nvSpPr>
         <p:spPr>
           <a:xfrm xmlns:a="http://schemas.openxmlformats.org/drawingml/2006/main">
-            <a:off x="666750" y="1581150"/>
-            <a:ext cx="10572750" cy="2914650"/>
+            <a:off x="666750" y="1447800"/>
+            <a:ext cx="10858500" cy="2657475"/>
           </a:xfrm>
           <a:prstGeom xmlns:a="http://schemas.openxmlformats.org/drawingml/2006/main" prst="rect">
             <a:avLst/>
@@ -1456,7 +1456,7 @@
           <a:lstStyle xmlns:a="http://schemas.openxmlformats.org/drawingml/2006/main"/>
           <a:p xmlns:a="http://schemas.openxmlformats.org/drawingml/2006/main">
             <a:pPr>
-              <a:defRPr sz="5850" b="1">
+              <a:defRPr sz="5250" b="1">
                 <a:solidFill>
                   <a:srgbClr val="F5F3EB"/>
                 </a:solidFill>
@@ -1466,7 +1466,7 @@
               </a:defRPr>
             </a:pPr>
             <a:r>
-              <a:rPr sz="5850" b="1">
+              <a:rPr sz="5250" b="1">
                 <a:solidFill>
                   <a:srgbClr val="F5F3EB"/>
                 </a:solidFill>
@@ -1474,12 +1474,12 @@
                 <a:ea typeface="IBM Plex Sans KR"/>
                 <a:cs typeface="IBM Plex Sans KR"/>
               </a:rPr>
-              <a:t>상품은 많은데,</a:t>
-            </a:r>
-          </a:p>
-          <a:p xmlns:a="http://schemas.openxmlformats.org/drawingml/2006/main">
-            <a:pPr>
-              <a:defRPr sz="5850" b="1">
+              <a:t>상품을 내 생활로</a:t>
+            </a:r>
+          </a:p>
+          <a:p xmlns:a="http://schemas.openxmlformats.org/drawingml/2006/main">
+            <a:pPr>
+              <a:defRPr sz="5250" b="1">
                 <a:solidFill>
                   <a:srgbClr val="F5F3EB"/>
                 </a:solidFill>
@@ -1489,7 +1489,7 @@
               </a:defRPr>
             </a:pPr>
             <a:r>
-              <a:rPr sz="5850" b="1">
+              <a:rPr sz="5250" b="1">
                 <a:solidFill>
                   <a:srgbClr val="F5F3EB"/>
                 </a:solidFill>
@@ -1497,12 +1497,12 @@
                 <a:ea typeface="IBM Plex Sans KR"/>
                 <a:cs typeface="IBM Plex Sans KR"/>
               </a:rPr>
-              <a:t>내 생활은</a:t>
-            </a:r>
-          </a:p>
-          <a:p xmlns:a="http://schemas.openxmlformats.org/drawingml/2006/main">
-            <a:pPr>
-              <a:defRPr sz="5850" b="1">
+              <a:t>번역하는 일은</a:t>
+            </a:r>
+          </a:p>
+          <a:p xmlns:a="http://schemas.openxmlformats.org/drawingml/2006/main">
+            <a:pPr>
+              <a:defRPr sz="5250" b="1">
                 <a:solidFill>
                   <a:srgbClr val="F5F3EB"/>
                 </a:solidFill>
@@ -1512,7 +1512,7 @@
               </a:defRPr>
             </a:pPr>
             <a:r>
-              <a:rPr sz="5850" b="1">
+              <a:rPr sz="5250" b="1">
                 <a:solidFill>
                   <a:srgbClr val="F5F3EB"/>
                 </a:solidFill>
@@ -1520,17 +1520,17 @@
                 <a:ea typeface="IBM Plex Sans KR"/>
                 <a:cs typeface="IBM Plex Sans KR"/>
               </a:rPr>
-              <a:t>잘 보이지 않는다</a:t>
-            </a:r>
-          </a:p>
-        </p:txBody>
-      </p:sp>
-      <p:sp>
-        <p:nvSpPr>
-          <p:cNvPr id="3" name="problem-description">
+              <a:t>고객에게 맡겨져 있다</a:t>
+            </a:r>
+          </a:p>
+        </p:txBody>
+      </p:sp>
+      <p:sp>
+        <p:nvSpPr>
+          <p:cNvPr id="3" name="why">
             <a:extLst xmlns:a="http://schemas.openxmlformats.org/drawingml/2006/main">
               <a:ext uri="{FF2B5EF4-FFF2-40B4-BE49-F238E27FC236}">
-                <a16:creationId xmlns:a16="http://schemas.microsoft.com/office/drawing/2014/main" id="{EF53988F-6459-48AB-AACB-C504D4E4F4B2}"/>
+                <a16:creationId xmlns:a16="http://schemas.microsoft.com/office/drawing/2014/main" id="{3F171FD6-17C9-4E99-AED3-5F1EA098CF81}"/>
               </a:ext>
             </a:extLst>
           </p:cNvPr>
@@ -1541,8 +1541,8 @@
         </p:nvSpPr>
         <p:spPr>
           <a:xfrm xmlns:a="http://schemas.openxmlformats.org/drawingml/2006/main">
-            <a:off x="723900" y="5000625"/>
-            <a:ext cx="8858250" cy="781050"/>
+            <a:off x="714375" y="4686300"/>
+            <a:ext cx="10572750" cy="866775"/>
           </a:xfrm>
           <a:prstGeom xmlns:a="http://schemas.openxmlformats.org/drawingml/2006/main" prst="rect">
             <a:avLst/>
@@ -1559,7 +1559,7 @@
           <a:lstStyle xmlns:a="http://schemas.openxmlformats.org/drawingml/2006/main"/>
           <a:p xmlns:a="http://schemas.openxmlformats.org/drawingml/2006/main">
             <a:pPr>
-              <a:defRPr sz="2175" b="0">
+              <a:defRPr sz="2325" b="0">
                 <a:solidFill>
                   <a:srgbClr val="D5DCCD"/>
                 </a:solidFill>
@@ -1569,7 +1569,7 @@
               </a:defRPr>
             </a:pPr>
             <a:r>
-              <a:rPr sz="2175" b="0">
+              <a:rPr sz="2325" b="0">
                 <a:solidFill>
                   <a:srgbClr val="D5DCCD"/>
                 </a:solidFill>
@@ -1577,12 +1577,12 @@
                 <a:ea typeface="IBM Plex Sans KR"/>
                 <a:cs typeface="IBM Plex Sans KR"/>
               </a:rPr>
-              <a:t>GS SHOP의 상품을 내 생활과 연결하기 어려운</a:t>
-            </a:r>
-          </a:p>
-          <a:p xmlns:a="http://schemas.openxmlformats.org/drawingml/2006/main">
-            <a:pPr>
-              <a:defRPr sz="2175" b="0">
+              <a:t>GS SHOP의 상품·가격·행사를 보고</a:t>
+            </a:r>
+          </a:p>
+          <a:p xmlns:a="http://schemas.openxmlformats.org/drawingml/2006/main">
+            <a:pPr>
+              <a:defRPr sz="2325" b="0">
                 <a:solidFill>
                   <a:srgbClr val="D5DCCD"/>
                 </a:solidFill>
@@ -1592,7 +1592,7 @@
               </a:defRPr>
             </a:pPr>
             <a:r>
-              <a:rPr sz="2175" b="0">
+              <a:rPr sz="2325" b="0">
                 <a:solidFill>
                   <a:srgbClr val="D5DCCD"/>
                 </a:solidFill>
@@ -1600,17 +1600,17 @@
                 <a:ea typeface="IBM Plex Sans KR"/>
                 <a:cs typeface="IBM Plex Sans KR"/>
               </a:rPr>
-              <a:t>2030 고객의 쇼핑 경험에서 출발했다</a:t>
-            </a:r>
-          </a:p>
-        </p:txBody>
-      </p:sp>
-      <p:sp>
-        <p:nvSpPr>
-          <p:cNvPr id="4" name="problem-disclosure">
+              <a:t>“내가 언제, 어떻게 쓸까”까지 스스로 연결해야 한다</a:t>
+            </a:r>
+          </a:p>
+        </p:txBody>
+      </p:sp>
+      <p:sp>
+        <p:nvSpPr>
+          <p:cNvPr id="4" name="footnote">
             <a:extLst xmlns:a="http://schemas.openxmlformats.org/drawingml/2006/main">
               <a:ext uri="{FF2B5EF4-FFF2-40B4-BE49-F238E27FC236}">
-                <a16:creationId xmlns:a16="http://schemas.microsoft.com/office/drawing/2014/main" id="{F57F8F41-B5EE-497E-82B1-6F567FE2835C}"/>
+                <a16:creationId xmlns:a16="http://schemas.microsoft.com/office/drawing/2014/main" id="{27971D8F-4180-4D86-862E-C891860D7C17}"/>
               </a:ext>
             </a:extLst>
           </p:cNvPr>
@@ -1621,8 +1621,8 @@
         </p:nvSpPr>
         <p:spPr>
           <a:xfrm xmlns:a="http://schemas.openxmlformats.org/drawingml/2006/main">
-            <a:off x="723900" y="6315075"/>
-            <a:ext cx="9525000" cy="247650"/>
+            <a:off x="685800" y="6362700"/>
+            <a:ext cx="10572750" cy="228600"/>
           </a:xfrm>
           <a:prstGeom xmlns:a="http://schemas.openxmlformats.org/drawingml/2006/main" prst="rect">
             <a:avLst/>
@@ -1639,9 +1639,66 @@
           <a:lstStyle xmlns:a="http://schemas.openxmlformats.org/drawingml/2006/main"/>
           <a:p xmlns:a="http://schemas.openxmlformats.org/drawingml/2006/main">
             <a:pPr>
+              <a:defRPr sz="1275" b="0">
+                <a:solidFill>
+                  <a:srgbClr val="AEBDA5"/>
+                </a:solidFill>
+                <a:latin typeface="IBM Plex Sans KR"/>
+                <a:ea typeface="IBM Plex Sans KR"/>
+                <a:cs typeface="IBM Plex Sans KR"/>
+              </a:defRPr>
+            </a:pPr>
+            <a:r>
+              <a:rPr sz="1275" b="0">
+                <a:solidFill>
+                  <a:srgbClr val="AEBDA5"/>
+                </a:solidFill>
+                <a:latin typeface="IBM Plex Sans KR"/>
+                <a:ea typeface="IBM Plex Sans KR"/>
+                <a:cs typeface="IBM Plex Sans KR"/>
+              </a:rPr>
+              <a:t>2030 고객이 상품과 자기 생활의 연결을 찾기 어렵다는 문제 가설</a:t>
+            </a:r>
+          </a:p>
+        </p:txBody>
+      </p:sp>
+      <p:sp>
+        <p:nvSpPr>
+          <p:cNvPr id="5" name="page">
+            <a:extLst xmlns:a="http://schemas.openxmlformats.org/drawingml/2006/main">
+              <a:ext uri="{FF2B5EF4-FFF2-40B4-BE49-F238E27FC236}">
+                <a16:creationId xmlns:a16="http://schemas.microsoft.com/office/drawing/2014/main" id="{EA5FC08F-A6DA-4EF0-A43E-49F174DAF2CA}"/>
+              </a:ext>
+            </a:extLst>
+          </p:cNvPr>
+          <p:cNvSpPr>
+            <a:spLocks xmlns:a="http://schemas.openxmlformats.org/drawingml/2006/main" noGrp="1"/>
+          </p:cNvSpPr>
+          <p:nvPr/>
+        </p:nvSpPr>
+        <p:spPr>
+          <a:xfrm xmlns:a="http://schemas.openxmlformats.org/drawingml/2006/main">
+            <a:off x="11287125" y="6353175"/>
+            <a:ext cx="381000" cy="247650"/>
+          </a:xfrm>
+          <a:prstGeom xmlns:a="http://schemas.openxmlformats.org/drawingml/2006/main" prst="rect">
+            <a:avLst/>
+          </a:prstGeom>
+          <a:noFill xmlns:a="http://schemas.openxmlformats.org/drawingml/2006/main"/>
+          <a:ln xmlns:a="http://schemas.openxmlformats.org/drawingml/2006/main" w="0">
+            <a:noFill/>
+          </a:ln>
+        </p:spPr>
+        <p:txBody>
+          <a:bodyPr xmlns:a="http://schemas.openxmlformats.org/drawingml/2006/main" wrap="square" lIns="0" tIns="0" rIns="0" bIns="0" anchor="t">
+            <a:noAutofit/>
+          </a:bodyPr>
+          <a:lstStyle xmlns:a="http://schemas.openxmlformats.org/drawingml/2006/main"/>
+          <a:p xmlns:a="http://schemas.openxmlformats.org/drawingml/2006/main">
+            <a:pPr>
               <a:defRPr sz="1350" b="0">
                 <a:solidFill>
-                  <a:srgbClr val="94A687"/>
+                  <a:srgbClr val="AEBDA5"/>
                 </a:solidFill>
                 <a:latin typeface="IBM Plex Sans KR"/>
                 <a:ea typeface="IBM Plex Sans KR"/>
@@ -1651,13 +1708,13 @@
             <a:r>
               <a:rPr sz="1350" b="0">
                 <a:solidFill>
-                  <a:srgbClr val="94A687"/>
-                </a:solidFill>
-                <a:latin typeface="IBM Plex Sans KR"/>
-                <a:ea typeface="IBM Plex Sans KR"/>
-                <a:cs typeface="IBM Plex Sans KR"/>
-              </a:rPr>
-              <a:t>기획에서 정의한 고객 문제 가설</a:t>
+                  <a:srgbClr val="AEBDA5"/>
+                </a:solidFill>
+                <a:latin typeface="IBM Plex Sans KR"/>
+                <a:ea typeface="IBM Plex Sans KR"/>
+                <a:cs typeface="IBM Plex Sans KR"/>
+              </a:rPr>
+              <a:t>01</a:t>
             </a:r>
           </a:p>
         </p:txBody>
@@ -1665,7 +1722,7 @@
     </p:spTree>
     <p:extLst>
       <p:ext uri="{BB962C8B-B14F-4D97-AF65-F5344CB8AC3E}">
-        <p14:creationId xmlns:p14="http://schemas.microsoft.com/office/powerpoint/2010/main" val="712669169"/>
+        <p14:creationId xmlns:p14="http://schemas.microsoft.com/office/powerpoint/2010/main" val="978357995"/>
       </p:ext>
     </p:extLst>
   </p:cSld>
@@ -1693,10 +1750,10 @@
       </p:grpSpPr>
       <p:sp>
         <p:nvSpPr>
-          <p:cNvPr id="6" name="reframe-title">
+          <p:cNvPr id="8" name="brand">
             <a:extLst xmlns:a="http://schemas.openxmlformats.org/drawingml/2006/main">
               <a:ext uri="{FF2B5EF4-FFF2-40B4-BE49-F238E27FC236}">
-                <a16:creationId xmlns:a16="http://schemas.microsoft.com/office/drawing/2014/main" id="{FAE7D558-2C00-4E76-A132-87F68D8B151C}"/>
+                <a16:creationId xmlns:a16="http://schemas.microsoft.com/office/drawing/2014/main" id="{19E9EC6B-43DB-4A67-A9D8-D58013CB7098}"/>
               </a:ext>
             </a:extLst>
           </p:cNvPr>
@@ -1707,8 +1764,8 @@
         </p:nvSpPr>
         <p:spPr>
           <a:xfrm xmlns:a="http://schemas.openxmlformats.org/drawingml/2006/main">
-            <a:off x="666750" y="723900"/>
-            <a:ext cx="10477500" cy="1714500"/>
+            <a:off x="666750" y="495300"/>
+            <a:ext cx="5905500" cy="857250"/>
           </a:xfrm>
           <a:prstGeom xmlns:a="http://schemas.openxmlformats.org/drawingml/2006/main" prst="rect">
             <a:avLst/>
@@ -1725,7 +1782,7 @@
           <a:lstStyle xmlns:a="http://schemas.openxmlformats.org/drawingml/2006/main"/>
           <a:p xmlns:a="http://schemas.openxmlformats.org/drawingml/2006/main">
             <a:pPr>
-              <a:defRPr sz="4800" b="1">
+              <a:defRPr sz="5700" b="1">
                 <a:solidFill>
                   <a:srgbClr val="263F35"/>
                 </a:solidFill>
@@ -1735,7 +1792,7 @@
               </a:defRPr>
             </a:pPr>
             <a:r>
-              <a:rPr sz="4800" b="1">
+              <a:rPr sz="5700" b="1">
                 <a:solidFill>
                   <a:srgbClr val="263F35"/>
                 </a:solidFill>
@@ -1743,40 +1800,17 @@
                 <a:ea typeface="IBM Plex Sans KR"/>
                 <a:cs typeface="IBM Plex Sans KR"/>
               </a:rPr>
-              <a:t>이 상품이 내 생활</a:t>
-            </a:r>
-          </a:p>
-          <a:p xmlns:a="http://schemas.openxmlformats.org/drawingml/2006/main">
-            <a:pPr>
-              <a:defRPr sz="4800" b="1">
-                <a:solidFill>
-                  <a:srgbClr val="263F35"/>
-                </a:solidFill>
-                <a:latin typeface="IBM Plex Sans KR"/>
-                <a:ea typeface="IBM Plex Sans KR"/>
-                <a:cs typeface="IBM Plex Sans KR"/>
-              </a:defRPr>
-            </a:pPr>
-            <a:r>
-              <a:rPr sz="4800" b="1">
-                <a:solidFill>
-                  <a:srgbClr val="263F35"/>
-                </a:solidFill>
-                <a:latin typeface="IBM Plex Sans KR"/>
-                <a:ea typeface="IBM Plex Sans KR"/>
-                <a:cs typeface="IBM Plex Sans KR"/>
-              </a:rPr>
-              <a:t>어디에 들어올까?</a:t>
-            </a:r>
-          </a:p>
-        </p:txBody>
-      </p:sp>
-      <p:sp>
-        <p:nvSpPr>
-          <p:cNvPr id="2" name="reframe-body">
+              <a:t>G:Scene</a:t>
+            </a:r>
+          </a:p>
+        </p:txBody>
+      </p:sp>
+      <p:sp>
+        <p:nvSpPr>
+          <p:cNvPr id="2" name="title">
             <a:extLst xmlns:a="http://schemas.openxmlformats.org/drawingml/2006/main">
               <a:ext uri="{FF2B5EF4-FFF2-40B4-BE49-F238E27FC236}">
-                <a16:creationId xmlns:a16="http://schemas.microsoft.com/office/drawing/2014/main" id="{DC3EC422-70DE-4541-85F8-1F408FF947E2}"/>
+                <a16:creationId xmlns:a16="http://schemas.microsoft.com/office/drawing/2014/main" id="{9E97E77C-6AF3-4F38-BEF3-EF46ED9E762C}"/>
               </a:ext>
             </a:extLst>
           </p:cNvPr>
@@ -1787,8 +1821,8 @@
         </p:nvSpPr>
         <p:spPr>
           <a:xfrm xmlns:a="http://schemas.openxmlformats.org/drawingml/2006/main">
-            <a:off x="714375" y="3295650"/>
-            <a:ext cx="5143500" cy="1104900"/>
+            <a:off x="704850" y="1924050"/>
+            <a:ext cx="6286500" cy="1428750"/>
           </a:xfrm>
           <a:prstGeom xmlns:a="http://schemas.openxmlformats.org/drawingml/2006/main" prst="rect">
             <a:avLst/>
@@ -1805,7 +1839,7 @@
           <a:lstStyle xmlns:a="http://schemas.openxmlformats.org/drawingml/2006/main"/>
           <a:p xmlns:a="http://schemas.openxmlformats.org/drawingml/2006/main">
             <a:pPr>
-              <a:defRPr sz="2550" b="0">
+              <a:defRPr sz="3675" b="1">
                 <a:solidFill>
                   <a:srgbClr val="263F35"/>
                 </a:solidFill>
@@ -1815,7 +1849,7 @@
               </a:defRPr>
             </a:pPr>
             <a:r>
-              <a:rPr sz="2550" b="0">
+              <a:rPr sz="3675" b="1">
                 <a:solidFill>
                   <a:srgbClr val="263F35"/>
                 </a:solidFill>
@@ -1823,12 +1857,12 @@
                 <a:ea typeface="IBM Plex Sans KR"/>
                 <a:cs typeface="IBM Plex Sans KR"/>
               </a:rPr>
-              <a:t>이미 가진 물건에서 출발해</a:t>
-            </a:r>
-          </a:p>
-          <a:p xmlns:a="http://schemas.openxmlformats.org/drawingml/2006/main">
-            <a:pPr>
-              <a:defRPr sz="2550" b="0">
+              <a:t>내가 가진 물건에서</a:t>
+            </a:r>
+          </a:p>
+          <a:p xmlns:a="http://schemas.openxmlformats.org/drawingml/2006/main">
+            <a:pPr>
+              <a:defRPr sz="3675" b="1">
                 <a:solidFill>
                   <a:srgbClr val="263F35"/>
                 </a:solidFill>
@@ -1838,7 +1872,7 @@
               </a:defRPr>
             </a:pPr>
             <a:r>
-              <a:rPr sz="2550" b="0">
+              <a:rPr sz="3675" b="1">
                 <a:solidFill>
                   <a:srgbClr val="263F35"/>
                 </a:solidFill>
@@ -1846,27 +1880,187 @@
                 <a:ea typeface="IBM Plex Sans KR"/>
                 <a:cs typeface="IBM Plex Sans KR"/>
               </a:rPr>
-              <a:t>다음 쇼핑의 이유를 만든다</a:t>
+              <a:t>다음 필요를 찾는다</a:t>
+            </a:r>
+          </a:p>
+        </p:txBody>
+      </p:sp>
+      <p:sp>
+        <p:nvSpPr>
+          <p:cNvPr id="3" name="why">
+            <a:extLst xmlns:a="http://schemas.openxmlformats.org/drawingml/2006/main">
+              <a:ext uri="{FF2B5EF4-FFF2-40B4-BE49-F238E27FC236}">
+                <a16:creationId xmlns:a16="http://schemas.microsoft.com/office/drawing/2014/main" id="{2F6344A5-EA70-4BC8-85AA-69791F904562}"/>
+              </a:ext>
+            </a:extLst>
+          </p:cNvPr>
+          <p:cNvSpPr>
+            <a:spLocks xmlns:a="http://schemas.openxmlformats.org/drawingml/2006/main" noGrp="1"/>
+          </p:cNvSpPr>
+          <p:nvPr/>
+        </p:nvSpPr>
+        <p:spPr>
+          <a:xfrm xmlns:a="http://schemas.openxmlformats.org/drawingml/2006/main">
+            <a:off x="723900" y="3771900"/>
+            <a:ext cx="5619750" cy="895350"/>
+          </a:xfrm>
+          <a:prstGeom xmlns:a="http://schemas.openxmlformats.org/drawingml/2006/main" prst="rect">
+            <a:avLst/>
+          </a:prstGeom>
+          <a:noFill xmlns:a="http://schemas.openxmlformats.org/drawingml/2006/main"/>
+          <a:ln xmlns:a="http://schemas.openxmlformats.org/drawingml/2006/main" w="0">
+            <a:noFill/>
+          </a:ln>
+        </p:spPr>
+        <p:txBody>
+          <a:bodyPr xmlns:a="http://schemas.openxmlformats.org/drawingml/2006/main" wrap="square" lIns="0" tIns="0" rIns="0" bIns="0" anchor="t">
+            <a:noAutofit/>
+          </a:bodyPr>
+          <a:lstStyle xmlns:a="http://schemas.openxmlformats.org/drawingml/2006/main"/>
+          <a:p xmlns:a="http://schemas.openxmlformats.org/drawingml/2006/main">
+            <a:pPr>
+              <a:defRPr sz="2175" b="0">
+                <a:solidFill>
+                  <a:srgbClr val="263F35"/>
+                </a:solidFill>
+                <a:latin typeface="IBM Plex Sans KR"/>
+                <a:ea typeface="IBM Plex Sans KR"/>
+                <a:cs typeface="IBM Plex Sans KR"/>
+              </a:defRPr>
+            </a:pPr>
+            <a:r>
+              <a:rPr sz="2175" b="0">
+                <a:solidFill>
+                  <a:srgbClr val="263F35"/>
+                </a:solidFill>
+                <a:latin typeface="IBM Plex Sans KR"/>
+                <a:ea typeface="IBM Plex Sans KR"/>
+                <a:cs typeface="IBM Plex Sans KR"/>
+              </a:rPr>
+              <a:t>이미 가진 옷을 보면</a:t>
+            </a:r>
+          </a:p>
+          <a:p xmlns:a="http://schemas.openxmlformats.org/drawingml/2006/main">
+            <a:pPr>
+              <a:defRPr sz="2175" b="0">
+                <a:solidFill>
+                  <a:srgbClr val="263F35"/>
+                </a:solidFill>
+                <a:latin typeface="IBM Plex Sans KR"/>
+                <a:ea typeface="IBM Plex Sans KR"/>
+                <a:cs typeface="IBM Plex Sans KR"/>
+              </a:defRPr>
+            </a:pPr>
+            <a:r>
+              <a:rPr sz="2175" b="0">
+                <a:solidFill>
+                  <a:srgbClr val="263F35"/>
+                </a:solidFill>
+                <a:latin typeface="IBM Plex Sans KR"/>
+                <a:ea typeface="IBM Plex Sans KR"/>
+                <a:cs typeface="IBM Plex Sans KR"/>
+              </a:rPr>
+              <a:t>새 상품을 더할 장면이 구체적이다</a:t>
+            </a:r>
+          </a:p>
+        </p:txBody>
+      </p:sp>
+      <p:sp>
+        <p:nvSpPr>
+          <p:cNvPr id="4" name="example">
+            <a:extLst xmlns:a="http://schemas.openxmlformats.org/drawingml/2006/main">
+              <a:ext uri="{FF2B5EF4-FFF2-40B4-BE49-F238E27FC236}">
+                <a16:creationId xmlns:a16="http://schemas.microsoft.com/office/drawing/2014/main" id="{B07217E3-AF23-4E22-9307-A3C54FEC05B8}"/>
+              </a:ext>
+            </a:extLst>
+          </p:cNvPr>
+          <p:cNvSpPr>
+            <a:spLocks xmlns:a="http://schemas.openxmlformats.org/drawingml/2006/main" noGrp="1"/>
+          </p:cNvSpPr>
+          <p:nvPr/>
+        </p:nvSpPr>
+        <p:spPr>
+          <a:xfrm xmlns:a="http://schemas.openxmlformats.org/drawingml/2006/main">
+            <a:off x="723900" y="5114925"/>
+            <a:ext cx="5734050" cy="809625"/>
+          </a:xfrm>
+          <a:prstGeom xmlns:a="http://schemas.openxmlformats.org/drawingml/2006/main" prst="rect">
+            <a:avLst/>
+          </a:prstGeom>
+          <a:noFill xmlns:a="http://schemas.openxmlformats.org/drawingml/2006/main"/>
+          <a:ln xmlns:a="http://schemas.openxmlformats.org/drawingml/2006/main" w="0">
+            <a:noFill/>
+          </a:ln>
+        </p:spPr>
+        <p:txBody>
+          <a:bodyPr xmlns:a="http://schemas.openxmlformats.org/drawingml/2006/main" wrap="square" lIns="0" tIns="0" rIns="0" bIns="0" anchor="t">
+            <a:noAutofit/>
+          </a:bodyPr>
+          <a:lstStyle xmlns:a="http://schemas.openxmlformats.org/drawingml/2006/main"/>
+          <a:p xmlns:a="http://schemas.openxmlformats.org/drawingml/2006/main">
+            <a:pPr>
+              <a:defRPr sz="2025" b="0">
+                <a:solidFill>
+                  <a:srgbClr val="667963"/>
+                </a:solidFill>
+                <a:latin typeface="IBM Plex Sans KR"/>
+                <a:ea typeface="IBM Plex Sans KR"/>
+                <a:cs typeface="IBM Plex Sans KR"/>
+              </a:defRPr>
+            </a:pPr>
+            <a:r>
+              <a:rPr sz="2025" b="0">
+                <a:solidFill>
+                  <a:srgbClr val="667963"/>
+                </a:solidFill>
+                <a:latin typeface="IBM Plex Sans KR"/>
+                <a:ea typeface="IBM Plex Sans KR"/>
+                <a:cs typeface="IBM Plex Sans KR"/>
+              </a:rPr>
+              <a:t>내 옷장 앞에서</a:t>
+            </a:r>
+          </a:p>
+          <a:p xmlns:a="http://schemas.openxmlformats.org/drawingml/2006/main">
+            <a:pPr>
+              <a:defRPr sz="2025" b="0">
+                <a:solidFill>
+                  <a:srgbClr val="667963"/>
+                </a:solidFill>
+                <a:latin typeface="IBM Plex Sans KR"/>
+                <a:ea typeface="IBM Plex Sans KR"/>
+                <a:cs typeface="IBM Plex Sans KR"/>
+              </a:defRPr>
+            </a:pPr>
+            <a:r>
+              <a:rPr sz="2025" b="0">
+                <a:solidFill>
+                  <a:srgbClr val="667963"/>
+                </a:solidFill>
+                <a:latin typeface="IBM Plex Sans KR"/>
+                <a:ea typeface="IBM Plex Sans KR"/>
+                <a:cs typeface="IBM Plex Sans KR"/>
+              </a:rPr>
+              <a:t>“내일 출근할 때 뭘 더할까?”</a:t>
             </a:r>
           </a:p>
         </p:txBody>
       </p:sp>
       <p:pic>
         <p:nvPicPr>
-          <p:cNvPr id="8" name=""/>
+          <p:cNvPr id="12" name=""/>
           <p:cNvPicPr>
             <a:picLocks xmlns:a="http://schemas.openxmlformats.org/drawingml/2006/main" noChangeAspect="1"/>
           </p:cNvPicPr>
           <p:nvPr/>
         </p:nvPicPr>
         <p:blipFill>
-          <a:blip xmlns:r="http://schemas.openxmlformats.org/officeDocument/2006/relationships" xmlns:a="http://schemas.openxmlformats.org/drawingml/2006/main" r:embed="R086b15588b8d42df"/>
+          <a:blip xmlns:r="http://schemas.openxmlformats.org/officeDocument/2006/relationships" xmlns:a="http://schemas.openxmlformats.org/drawingml/2006/main" r:embed="R23c35074363141ef"/>
           <a:stretch xmlns:a="http://schemas.openxmlformats.org/drawingml/2006/main"/>
         </p:blipFill>
         <p:spPr>
           <a:xfrm xmlns:a="http://schemas.openxmlformats.org/drawingml/2006/main">
-            <a:off x="6567733" y="3086100"/>
-            <a:ext cx="4619134" cy="1524000"/>
+            <a:off x="7353829" y="428625"/>
+            <a:ext cx="3989917" cy="5800725"/>
           </a:xfrm>
           <a:prstGeom xmlns:a="http://schemas.openxmlformats.org/drawingml/2006/main" prst="rect">
             <a:avLst/>
@@ -1875,10 +2069,10 @@
       </p:pic>
       <p:sp>
         <p:nvSpPr>
-          <p:cNvPr id="4" name="room-caption">
+          <p:cNvPr id="6" name="footnote">
             <a:extLst xmlns:a="http://schemas.openxmlformats.org/drawingml/2006/main">
               <a:ext uri="{FF2B5EF4-FFF2-40B4-BE49-F238E27FC236}">
-                <a16:creationId xmlns:a16="http://schemas.microsoft.com/office/drawing/2014/main" id="{93248F09-9F9A-4821-A3C0-D9DFC405F322}"/>
+                <a16:creationId xmlns:a16="http://schemas.microsoft.com/office/drawing/2014/main" id="{8E404454-8911-406B-B527-3144C82C9F88}"/>
               </a:ext>
             </a:extLst>
           </p:cNvPr>
@@ -1889,8 +2083,8 @@
         </p:nvSpPr>
         <p:spPr>
           <a:xfrm xmlns:a="http://schemas.openxmlformats.org/drawingml/2006/main">
-            <a:off x="6534150" y="4895850"/>
-            <a:ext cx="4857750" cy="400050"/>
+            <a:off x="685800" y="6362700"/>
+            <a:ext cx="10572750" cy="228600"/>
           </a:xfrm>
           <a:prstGeom xmlns:a="http://schemas.openxmlformats.org/drawingml/2006/main" prst="rect">
             <a:avLst/>
@@ -1907,7 +2101,7 @@
           <a:lstStyle xmlns:a="http://schemas.openxmlformats.org/drawingml/2006/main"/>
           <a:p xmlns:a="http://schemas.openxmlformats.org/drawingml/2006/main">
             <a:pPr>
-              <a:defRPr sz="1650" b="0">
+              <a:defRPr sz="1275" b="0">
                 <a:solidFill>
                   <a:srgbClr val="667963"/>
                 </a:solidFill>
@@ -1917,7 +2111,7 @@
               </a:defRPr>
             </a:pPr>
             <a:r>
-              <a:rPr sz="1650" b="0">
+              <a:rPr sz="1275" b="0">
                 <a:solidFill>
                   <a:srgbClr val="667963"/>
                 </a:solidFill>
@@ -1925,17 +2119,17 @@
                 <a:ea typeface="IBM Plex Sans KR"/>
                 <a:cs typeface="IBM Plex Sans KR"/>
               </a:rPr>
-              <a:t>내가 가진 쿠션과 조명이 놓인 거실</a:t>
-            </a:r>
-          </a:p>
-        </p:txBody>
-      </p:sp>
-      <p:sp>
-        <p:nvSpPr>
-          <p:cNvPr id="5" name="reframe-note">
+              <a:t>실제 prototype. 가상 고객의 구매 물건과 공간 그림. 생활 질문은 사용 장면 예시</a:t>
+            </a:r>
+          </a:p>
+        </p:txBody>
+      </p:sp>
+      <p:sp>
+        <p:nvSpPr>
+          <p:cNvPr id="7" name="page">
             <a:extLst xmlns:a="http://schemas.openxmlformats.org/drawingml/2006/main">
               <a:ext uri="{FF2B5EF4-FFF2-40B4-BE49-F238E27FC236}">
-                <a16:creationId xmlns:a16="http://schemas.microsoft.com/office/drawing/2014/main" id="{B997D4F7-491C-4B51-9B7D-4B36E6822B98}"/>
+                <a16:creationId xmlns:a16="http://schemas.microsoft.com/office/drawing/2014/main" id="{C0B77821-99C4-4412-BB6B-765AB3CDFFA0}"/>
               </a:ext>
             </a:extLst>
           </p:cNvPr>
@@ -1946,8 +2140,8 @@
         </p:nvSpPr>
         <p:spPr>
           <a:xfrm xmlns:a="http://schemas.openxmlformats.org/drawingml/2006/main">
-            <a:off x="714375" y="6276975"/>
-            <a:ext cx="10572750" cy="323850"/>
+            <a:off x="11287125" y="6353175"/>
+            <a:ext cx="381000" cy="247650"/>
           </a:xfrm>
           <a:prstGeom xmlns:a="http://schemas.openxmlformats.org/drawingml/2006/main" prst="rect">
             <a:avLst/>
@@ -1982,7 +2176,7 @@
                 <a:ea typeface="IBM Plex Sans KR"/>
                 <a:cs typeface="IBM Plex Sans KR"/>
               </a:rPr>
-              <a:t>공간 그림은 상품의 정확한 외형을 재현하지 않는 예시</a:t>
+              <a:t>02</a:t>
             </a:r>
           </a:p>
         </p:txBody>
@@ -1990,7 +2184,7 @@
     </p:spTree>
     <p:extLst>
       <p:ext uri="{BB962C8B-B14F-4D97-AF65-F5344CB8AC3E}">
-        <p14:creationId xmlns:p14="http://schemas.microsoft.com/office/powerpoint/2010/main" val="820270008"/>
+        <p14:creationId xmlns:p14="http://schemas.microsoft.com/office/powerpoint/2010/main" val="182273252"/>
       </p:ext>
     </p:extLst>
   </p:cSld>
@@ -2018,10 +2212,10 @@
       </p:grpSpPr>
       <p:sp>
         <p:nvSpPr>
-          <p:cNvPr id="6" name="product-brand">
+          <p:cNvPr id="9" name="eyebrow">
             <a:extLst xmlns:a="http://schemas.openxmlformats.org/drawingml/2006/main">
               <a:ext uri="{FF2B5EF4-FFF2-40B4-BE49-F238E27FC236}">
-                <a16:creationId xmlns:a16="http://schemas.microsoft.com/office/drawing/2014/main" id="{CF45F96B-5268-4F7B-953D-FA45FE140E39}"/>
+                <a16:creationId xmlns:a16="http://schemas.microsoft.com/office/drawing/2014/main" id="{2A8A5D47-6467-4E3D-8AFC-F0EC39B3661F}"/>
               </a:ext>
             </a:extLst>
           </p:cNvPr>
@@ -2032,8 +2226,8 @@
         </p:nvSpPr>
         <p:spPr>
           <a:xfrm xmlns:a="http://schemas.openxmlformats.org/drawingml/2006/main">
-            <a:off x="666750" y="781050"/>
-            <a:ext cx="6096000" cy="1190625"/>
+            <a:off x="666750" y="485775"/>
+            <a:ext cx="10668000" cy="381000"/>
           </a:xfrm>
           <a:prstGeom xmlns:a="http://schemas.openxmlformats.org/drawingml/2006/main" prst="rect">
             <a:avLst/>
@@ -2050,35 +2244,35 @@
           <a:lstStyle xmlns:a="http://schemas.openxmlformats.org/drawingml/2006/main"/>
           <a:p xmlns:a="http://schemas.openxmlformats.org/drawingml/2006/main">
             <a:pPr>
-              <a:defRPr sz="7200" b="1">
-                <a:solidFill>
-                  <a:srgbClr val="263F35"/>
-                </a:solidFill>
-                <a:latin typeface="IBM Plex Sans KR"/>
-                <a:ea typeface="IBM Plex Sans KR"/>
-                <a:cs typeface="IBM Plex Sans KR"/>
-              </a:defRPr>
-            </a:pPr>
-            <a:r>
-              <a:rPr sz="7200" b="1">
-                <a:solidFill>
-                  <a:srgbClr val="263F35"/>
-                </a:solidFill>
-                <a:latin typeface="IBM Plex Sans KR"/>
-                <a:ea typeface="IBM Plex Sans KR"/>
-                <a:cs typeface="IBM Plex Sans KR"/>
-              </a:rPr>
-              <a:t>G:Scene</a:t>
-            </a:r>
-          </a:p>
-        </p:txBody>
-      </p:sp>
-      <p:sp>
-        <p:nvSpPr>
-          <p:cNvPr id="2" name="product-definition">
+              <a:defRPr sz="1875" b="0">
+                <a:solidFill>
+                  <a:srgbClr val="667963"/>
+                </a:solidFill>
+                <a:latin typeface="IBM Plex Sans KR"/>
+                <a:ea typeface="IBM Plex Sans KR"/>
+                <a:cs typeface="IBM Plex Sans KR"/>
+              </a:defRPr>
+            </a:pPr>
+            <a:r>
+              <a:rPr sz="1875" b="0">
+                <a:solidFill>
+                  <a:srgbClr val="667963"/>
+                </a:solidFill>
+                <a:latin typeface="IBM Plex Sans KR"/>
+                <a:ea typeface="IBM Plex Sans KR"/>
+                <a:cs typeface="IBM Plex Sans KR"/>
+              </a:rPr>
+              <a:t>GS SHOP 자산과 연결할 생활 맥락</a:t>
+            </a:r>
+          </a:p>
+        </p:txBody>
+      </p:sp>
+      <p:sp>
+        <p:nvSpPr>
+          <p:cNvPr id="2" name="title">
             <a:extLst xmlns:a="http://schemas.openxmlformats.org/drawingml/2006/main">
               <a:ext uri="{FF2B5EF4-FFF2-40B4-BE49-F238E27FC236}">
-                <a16:creationId xmlns:a16="http://schemas.microsoft.com/office/drawing/2014/main" id="{66113A07-61C1-48E9-B5DA-2B485D82FAC9}"/>
+                <a16:creationId xmlns:a16="http://schemas.microsoft.com/office/drawing/2014/main" id="{B7F01354-2D4C-4085-A61D-E4E89BD2B8CE}"/>
               </a:ext>
             </a:extLst>
           </p:cNvPr>
@@ -2089,8 +2283,8 @@
         </p:nvSpPr>
         <p:spPr>
           <a:xfrm xmlns:a="http://schemas.openxmlformats.org/drawingml/2006/main">
-            <a:off x="723900" y="2495550"/>
-            <a:ext cx="6019800" cy="1676400"/>
+            <a:off x="666750" y="1314450"/>
+            <a:ext cx="6772275" cy="2009775"/>
           </a:xfrm>
           <a:prstGeom xmlns:a="http://schemas.openxmlformats.org/drawingml/2006/main" prst="rect">
             <a:avLst/>
@@ -2107,7 +2301,7 @@
           <a:lstStyle xmlns:a="http://schemas.openxmlformats.org/drawingml/2006/main"/>
           <a:p xmlns:a="http://schemas.openxmlformats.org/drawingml/2006/main">
             <a:pPr>
-              <a:defRPr sz="3900" b="1">
+              <a:defRPr sz="4050" b="1">
                 <a:solidFill>
                   <a:srgbClr val="263F35"/>
                 </a:solidFill>
@@ -2117,7 +2311,7 @@
               </a:defRPr>
             </a:pPr>
             <a:r>
-              <a:rPr sz="3900" b="1">
+              <a:rPr sz="4050" b="1">
                 <a:solidFill>
                   <a:srgbClr val="263F35"/>
                 </a:solidFill>
@@ -2125,12 +2319,12 @@
                 <a:ea typeface="IBM Plex Sans KR"/>
                 <a:cs typeface="IBM Plex Sans KR"/>
               </a:rPr>
-              <a:t>내가 산 물건과</a:t>
-            </a:r>
-          </a:p>
-          <a:p xmlns:a="http://schemas.openxmlformats.org/drawingml/2006/main">
-            <a:pPr>
-              <a:defRPr sz="3900" b="1">
+              <a:t>내 옷에,</a:t>
+            </a:r>
+          </a:p>
+          <a:p xmlns:a="http://schemas.openxmlformats.org/drawingml/2006/main">
+            <a:pPr>
+              <a:defRPr sz="4050" b="1">
                 <a:solidFill>
                   <a:srgbClr val="263F35"/>
                 </a:solidFill>
@@ -2140,7 +2334,7 @@
               </a:defRPr>
             </a:pPr>
             <a:r>
-              <a:rPr sz="3900" b="1">
+              <a:rPr sz="4050" b="1">
                 <a:solidFill>
                   <a:srgbClr val="263F35"/>
                 </a:solidFill>
@@ -2148,17 +2342,40 @@
                 <a:ea typeface="IBM Plex Sans KR"/>
                 <a:cs typeface="IBM Plex Sans KR"/>
               </a:rPr>
-              <a:t>살아가는 나의 공간</a:t>
-            </a:r>
-          </a:p>
-        </p:txBody>
-      </p:sp>
-      <p:sp>
-        <p:nvSpPr>
-          <p:cNvPr id="3" name="product-behavior">
+              <a:t>내일의 출근을</a:t>
+            </a:r>
+          </a:p>
+          <a:p xmlns:a="http://schemas.openxmlformats.org/drawingml/2006/main">
+            <a:pPr>
+              <a:defRPr sz="4050" b="1">
+                <a:solidFill>
+                  <a:srgbClr val="263F35"/>
+                </a:solidFill>
+                <a:latin typeface="IBM Plex Sans KR"/>
+                <a:ea typeface="IBM Plex Sans KR"/>
+                <a:cs typeface="IBM Plex Sans KR"/>
+              </a:defRPr>
+            </a:pPr>
+            <a:r>
+              <a:rPr sz="4050" b="1">
+                <a:solidFill>
+                  <a:srgbClr val="263F35"/>
+                </a:solidFill>
+                <a:latin typeface="IBM Plex Sans KR"/>
+                <a:ea typeface="IBM Plex Sans KR"/>
+                <a:cs typeface="IBM Plex Sans KR"/>
+              </a:rPr>
+              <a:t>더하면</a:t>
+            </a:r>
+          </a:p>
+        </p:txBody>
+      </p:sp>
+      <p:sp>
+        <p:nvSpPr>
+          <p:cNvPr id="3" name="why">
             <a:extLst xmlns:a="http://schemas.openxmlformats.org/drawingml/2006/main">
               <a:ext uri="{FF2B5EF4-FFF2-40B4-BE49-F238E27FC236}">
-                <a16:creationId xmlns:a16="http://schemas.microsoft.com/office/drawing/2014/main" id="{BC2596AA-91E8-45DB-BAFC-F31CA5805AB2}"/>
+                <a16:creationId xmlns:a16="http://schemas.microsoft.com/office/drawing/2014/main" id="{F56D4A63-203F-4662-933A-76F8D845EE0F}"/>
               </a:ext>
             </a:extLst>
           </p:cNvPr>
@@ -2169,8 +2386,8 @@
         </p:nvSpPr>
         <p:spPr>
           <a:xfrm xmlns:a="http://schemas.openxmlformats.org/drawingml/2006/main">
-            <a:off x="742950" y="4572000"/>
-            <a:ext cx="5486400" cy="847725"/>
+            <a:off x="714375" y="3781425"/>
+            <a:ext cx="6438900" cy="914400"/>
           </a:xfrm>
           <a:prstGeom xmlns:a="http://schemas.openxmlformats.org/drawingml/2006/main" prst="rect">
             <a:avLst/>
@@ -2187,7 +2404,87 @@
           <a:lstStyle xmlns:a="http://schemas.openxmlformats.org/drawingml/2006/main"/>
           <a:p xmlns:a="http://schemas.openxmlformats.org/drawingml/2006/main">
             <a:pPr>
-              <a:defRPr sz="2100" b="0">
+              <a:defRPr sz="2250" b="0">
+                <a:solidFill>
+                  <a:srgbClr val="263F35"/>
+                </a:solidFill>
+                <a:latin typeface="IBM Plex Sans KR"/>
+                <a:ea typeface="IBM Plex Sans KR"/>
+                <a:cs typeface="IBM Plex Sans KR"/>
+              </a:defRPr>
+            </a:pPr>
+            <a:r>
+              <a:rPr sz="2250" b="0">
+                <a:solidFill>
+                  <a:srgbClr val="263F35"/>
+                </a:solidFill>
+                <a:latin typeface="IBM Plex Sans KR"/>
+                <a:ea typeface="IBM Plex Sans KR"/>
+                <a:cs typeface="IBM Plex Sans KR"/>
+              </a:rPr>
+              <a:t>보유 옷과 상황·예산으로</a:t>
+            </a:r>
+          </a:p>
+          <a:p xmlns:a="http://schemas.openxmlformats.org/drawingml/2006/main">
+            <a:pPr>
+              <a:defRPr sz="2250" b="0">
+                <a:solidFill>
+                  <a:srgbClr val="263F35"/>
+                </a:solidFill>
+                <a:latin typeface="IBM Plex Sans KR"/>
+                <a:ea typeface="IBM Plex Sans KR"/>
+                <a:cs typeface="IBM Plex Sans KR"/>
+              </a:defRPr>
+            </a:pPr>
+            <a:r>
+              <a:rPr sz="2250" b="0">
+                <a:solidFill>
+                  <a:srgbClr val="263F35"/>
+                </a:solidFill>
+                <a:latin typeface="IBM Plex Sans KR"/>
+                <a:ea typeface="IBM Plex Sans KR"/>
+                <a:cs typeface="IBM Plex Sans KR"/>
+              </a:rPr>
+              <a:t>상품을 고를 이유를 제안한다</a:t>
+            </a:r>
+          </a:p>
+        </p:txBody>
+      </p:sp>
+      <p:sp>
+        <p:nvSpPr>
+          <p:cNvPr id="4" name="evidence-label">
+            <a:extLst xmlns:a="http://schemas.openxmlformats.org/drawingml/2006/main">
+              <a:ext uri="{FF2B5EF4-FFF2-40B4-BE49-F238E27FC236}">
+                <a16:creationId xmlns:a16="http://schemas.microsoft.com/office/drawing/2014/main" id="{D8502919-8546-4C85-B836-27744B97500F}"/>
+              </a:ext>
+            </a:extLst>
+          </p:cNvPr>
+          <p:cNvSpPr>
+            <a:spLocks xmlns:a="http://schemas.openxmlformats.org/drawingml/2006/main" noGrp="1"/>
+          </p:cNvSpPr>
+          <p:nvPr/>
+        </p:nvSpPr>
+        <p:spPr>
+          <a:xfrm xmlns:a="http://schemas.openxmlformats.org/drawingml/2006/main">
+            <a:off x="714375" y="5105400"/>
+            <a:ext cx="6457950" cy="342900"/>
+          </a:xfrm>
+          <a:prstGeom xmlns:a="http://schemas.openxmlformats.org/drawingml/2006/main" prst="rect">
+            <a:avLst/>
+          </a:prstGeom>
+          <a:noFill xmlns:a="http://schemas.openxmlformats.org/drawingml/2006/main"/>
+          <a:ln xmlns:a="http://schemas.openxmlformats.org/drawingml/2006/main" w="0">
+            <a:noFill/>
+          </a:ln>
+        </p:spPr>
+        <p:txBody>
+          <a:bodyPr xmlns:a="http://schemas.openxmlformats.org/drawingml/2006/main" wrap="square" lIns="0" tIns="0" rIns="0" bIns="0" anchor="t">
+            <a:noAutofit/>
+          </a:bodyPr>
+          <a:lstStyle xmlns:a="http://schemas.openxmlformats.org/drawingml/2006/main"/>
+          <a:p xmlns:a="http://schemas.openxmlformats.org/drawingml/2006/main">
+            <a:pPr>
+              <a:defRPr sz="1725" b="0">
                 <a:solidFill>
                   <a:srgbClr val="667963"/>
                 </a:solidFill>
@@ -2197,7 +2494,7 @@
               </a:defRPr>
             </a:pPr>
             <a:r>
-              <a:rPr sz="2100" b="0">
+              <a:rPr sz="1725" b="0">
                 <a:solidFill>
                   <a:srgbClr val="667963"/>
                 </a:solidFill>
@@ -2205,50 +2502,107 @@
                 <a:ea typeface="IBM Plex Sans KR"/>
                 <a:cs typeface="IBM Plex Sans KR"/>
               </a:rPr>
-              <a:t>캐릭터가 움직이고,</a:t>
-            </a:r>
-          </a:p>
-          <a:p xmlns:a="http://schemas.openxmlformats.org/drawingml/2006/main">
-            <a:pPr>
-              <a:defRPr sz="2100" b="0">
-                <a:solidFill>
-                  <a:srgbClr val="667963"/>
-                </a:solidFill>
-                <a:latin typeface="IBM Plex Sans KR"/>
-                <a:ea typeface="IBM Plex Sans KR"/>
-                <a:cs typeface="IBM Plex Sans KR"/>
-              </a:defRPr>
-            </a:pPr>
-            <a:r>
-              <a:rPr sz="2100" b="0">
-                <a:solidFill>
-                  <a:srgbClr val="667963"/>
-                </a:solidFill>
-                <a:latin typeface="IBM Plex Sans KR"/>
-                <a:ea typeface="IBM Plex Sans KR"/>
-                <a:cs typeface="IBM Plex Sans KR"/>
-              </a:rPr>
-              <a:t>생활 속 물건이 쇼핑 입구가 된다</a:t>
+              <a:t>보유 크림 니트, 출근, 5만원 이하</a:t>
+            </a:r>
+          </a:p>
+        </p:txBody>
+      </p:sp>
+      <p:sp>
+        <p:nvSpPr>
+          <p:cNvPr id="5" name="evidence">
+            <a:extLst xmlns:a="http://schemas.openxmlformats.org/drawingml/2006/main">
+              <a:ext uri="{FF2B5EF4-FFF2-40B4-BE49-F238E27FC236}">
+                <a16:creationId xmlns:a16="http://schemas.microsoft.com/office/drawing/2014/main" id="{E358061C-7DF5-4C86-AC85-14863C7689B6}"/>
+              </a:ext>
+            </a:extLst>
+          </p:cNvPr>
+          <p:cNvSpPr>
+            <a:spLocks xmlns:a="http://schemas.openxmlformats.org/drawingml/2006/main" noGrp="1"/>
+          </p:cNvSpPr>
+          <p:nvPr/>
+        </p:nvSpPr>
+        <p:spPr>
+          <a:xfrm xmlns:a="http://schemas.openxmlformats.org/drawingml/2006/main">
+            <a:off x="714375" y="5476875"/>
+            <a:ext cx="6572250" cy="619125"/>
+          </a:xfrm>
+          <a:prstGeom xmlns:a="http://schemas.openxmlformats.org/drawingml/2006/main" prst="rect">
+            <a:avLst/>
+          </a:prstGeom>
+          <a:noFill xmlns:a="http://schemas.openxmlformats.org/drawingml/2006/main"/>
+          <a:ln xmlns:a="http://schemas.openxmlformats.org/drawingml/2006/main" w="0">
+            <a:noFill/>
+          </a:ln>
+        </p:spPr>
+        <p:txBody>
+          <a:bodyPr xmlns:a="http://schemas.openxmlformats.org/drawingml/2006/main" wrap="square" lIns="0" tIns="0" rIns="0" bIns="0" anchor="t">
+            <a:noAutofit/>
+          </a:bodyPr>
+          <a:lstStyle xmlns:a="http://schemas.openxmlformats.org/drawingml/2006/main"/>
+          <a:p xmlns:a="http://schemas.openxmlformats.org/drawingml/2006/main">
+            <a:pPr>
+              <a:defRPr sz="1875" b="0">
+                <a:solidFill>
+                  <a:srgbClr val="263F35"/>
+                </a:solidFill>
+                <a:latin typeface="IBM Plex Sans KR"/>
+                <a:ea typeface="IBM Plex Sans KR"/>
+                <a:cs typeface="IBM Plex Sans KR"/>
+              </a:defRPr>
+            </a:pPr>
+            <a:r>
+              <a:rPr sz="1875" b="0">
+                <a:solidFill>
+                  <a:srgbClr val="263F35"/>
+                </a:solidFill>
+                <a:latin typeface="IBM Plex Sans KR"/>
+                <a:ea typeface="IBM Plex Sans KR"/>
+                <a:cs typeface="IBM Plex Sans KR"/>
+              </a:rPr>
+              <a:t>“크림 니트와 차콜의 차분한 대비로</a:t>
+            </a:r>
+          </a:p>
+          <a:p xmlns:a="http://schemas.openxmlformats.org/drawingml/2006/main">
+            <a:pPr>
+              <a:defRPr sz="1875" b="0">
+                <a:solidFill>
+                  <a:srgbClr val="263F35"/>
+                </a:solidFill>
+                <a:latin typeface="IBM Plex Sans KR"/>
+                <a:ea typeface="IBM Plex Sans KR"/>
+                <a:cs typeface="IBM Plex Sans KR"/>
+              </a:defRPr>
+            </a:pPr>
+            <a:r>
+              <a:rPr sz="1875" b="0">
+                <a:solidFill>
+                  <a:srgbClr val="263F35"/>
+                </a:solidFill>
+                <a:latin typeface="IBM Plex Sans KR"/>
+                <a:ea typeface="IBM Plex Sans KR"/>
+                <a:cs typeface="IBM Plex Sans KR"/>
+              </a:rPr>
+              <a:t>출근 코디를 완성해요.”</a:t>
             </a:r>
           </a:p>
         </p:txBody>
       </p:sp>
       <p:pic>
         <p:nvPicPr>
-          <p:cNvPr id="9" name=""/>
+          <p:cNvPr id="14" name=""/>
           <p:cNvPicPr>
             <a:picLocks xmlns:a="http://schemas.openxmlformats.org/drawingml/2006/main" noChangeAspect="1"/>
           </p:cNvPicPr>
           <p:nvPr/>
         </p:nvPicPr>
         <p:blipFill>
-          <a:blip xmlns:r="http://schemas.openxmlformats.org/officeDocument/2006/relationships" xmlns:a="http://schemas.openxmlformats.org/drawingml/2006/main" r:embed="R22520a775bec4f42"/>
+          <a:blip xmlns:r="http://schemas.openxmlformats.org/officeDocument/2006/relationships" xmlns:a="http://schemas.openxmlformats.org/drawingml/2006/main" r:embed="R01aa7e431fa745ec"/>
           <a:stretch xmlns:a="http://schemas.openxmlformats.org/drawingml/2006/main"/>
         </p:blipFill>
         <p:spPr>
           <a:xfrm xmlns:a="http://schemas.openxmlformats.org/drawingml/2006/main">
-            <a:off x="7147849" y="361950"/>
-            <a:ext cx="4144701" cy="6162675"/>
+            <a:off x="7777163" y="1019175"/>
+            <a:ext cx="3457575" cy="5219700"/>
           </a:xfrm>
           <a:prstGeom xmlns:a="http://schemas.openxmlformats.org/drawingml/2006/main" prst="rect">
             <a:avLst/>
@@ -2257,10 +2611,10 @@
       </p:pic>
       <p:sp>
         <p:nvSpPr>
-          <p:cNvPr id="5" name="product-note">
+          <p:cNvPr id="7" name="footnote">
             <a:extLst xmlns:a="http://schemas.openxmlformats.org/drawingml/2006/main">
               <a:ext uri="{FF2B5EF4-FFF2-40B4-BE49-F238E27FC236}">
-                <a16:creationId xmlns:a16="http://schemas.microsoft.com/office/drawing/2014/main" id="{DA4F3394-FAE5-4E1D-A36D-CA274335E644}"/>
+                <a16:creationId xmlns:a16="http://schemas.microsoft.com/office/drawing/2014/main" id="{21399F52-E18B-41AB-A742-41AE64754FCA}"/>
               </a:ext>
             </a:extLst>
           </p:cNvPr>
@@ -2271,8 +2625,8 @@
         </p:nvSpPr>
         <p:spPr>
           <a:xfrm xmlns:a="http://schemas.openxmlformats.org/drawingml/2006/main">
-            <a:off x="742950" y="6219825"/>
-            <a:ext cx="6038850" cy="304800"/>
+            <a:off x="685800" y="6362700"/>
+            <a:ext cx="10572750" cy="228600"/>
           </a:xfrm>
           <a:prstGeom xmlns:a="http://schemas.openxmlformats.org/drawingml/2006/main" prst="rect">
             <a:avLst/>
@@ -2289,6 +2643,63 @@
           <a:lstStyle xmlns:a="http://schemas.openxmlformats.org/drawingml/2006/main"/>
           <a:p xmlns:a="http://schemas.openxmlformats.org/drawingml/2006/main">
             <a:pPr>
+              <a:defRPr sz="1275" b="0">
+                <a:solidFill>
+                  <a:srgbClr val="667963"/>
+                </a:solidFill>
+                <a:latin typeface="IBM Plex Sans KR"/>
+                <a:ea typeface="IBM Plex Sans KR"/>
+                <a:cs typeface="IBM Plex Sans KR"/>
+              </a:defRPr>
+            </a:pPr>
+            <a:r>
+              <a:rPr sz="1275" b="0">
+                <a:solidFill>
+                  <a:srgbClr val="667963"/>
+                </a:solidFill>
+                <a:latin typeface="IBM Plex Sans KR"/>
+                <a:ea typeface="IBM Plex Sans KR"/>
+                <a:cs typeface="IBM Plex Sans KR"/>
+              </a:rPr>
+              <a:t>실제 Fashion 조건 적용과 추천 이유. 추천 상품은 가상 예시이며, 고객 효과는 검증이 필요하다</a:t>
+            </a:r>
+          </a:p>
+        </p:txBody>
+      </p:sp>
+      <p:sp>
+        <p:nvSpPr>
+          <p:cNvPr id="8" name="page">
+            <a:extLst xmlns:a="http://schemas.openxmlformats.org/drawingml/2006/main">
+              <a:ext uri="{FF2B5EF4-FFF2-40B4-BE49-F238E27FC236}">
+                <a16:creationId xmlns:a16="http://schemas.microsoft.com/office/drawing/2014/main" id="{7D20E2C9-3D69-4318-A2A2-16B5500010B2}"/>
+              </a:ext>
+            </a:extLst>
+          </p:cNvPr>
+          <p:cNvSpPr>
+            <a:spLocks xmlns:a="http://schemas.openxmlformats.org/drawingml/2006/main" noGrp="1"/>
+          </p:cNvSpPr>
+          <p:nvPr/>
+        </p:nvSpPr>
+        <p:spPr>
+          <a:xfrm xmlns:a="http://schemas.openxmlformats.org/drawingml/2006/main">
+            <a:off x="11287125" y="6353175"/>
+            <a:ext cx="381000" cy="247650"/>
+          </a:xfrm>
+          <a:prstGeom xmlns:a="http://schemas.openxmlformats.org/drawingml/2006/main" prst="rect">
+            <a:avLst/>
+          </a:prstGeom>
+          <a:noFill xmlns:a="http://schemas.openxmlformats.org/drawingml/2006/main"/>
+          <a:ln xmlns:a="http://schemas.openxmlformats.org/drawingml/2006/main" w="0">
+            <a:noFill/>
+          </a:ln>
+        </p:spPr>
+        <p:txBody>
+          <a:bodyPr xmlns:a="http://schemas.openxmlformats.org/drawingml/2006/main" wrap="square" lIns="0" tIns="0" rIns="0" bIns="0" anchor="t">
+            <a:noAutofit/>
+          </a:bodyPr>
+          <a:lstStyle xmlns:a="http://schemas.openxmlformats.org/drawingml/2006/main"/>
+          <a:p xmlns:a="http://schemas.openxmlformats.org/drawingml/2006/main">
+            <a:pPr>
               <a:defRPr sz="1350" b="0">
                 <a:solidFill>
                   <a:srgbClr val="667963"/>
@@ -2307,7 +2718,7 @@
                 <a:ea typeface="IBM Plex Sans KR"/>
                 <a:cs typeface="IBM Plex Sans KR"/>
               </a:rPr>
-              <a:t>가상 고객의 구매 상태를 연결한 실제 prototype</a:t>
+              <a:t>03</a:t>
             </a:r>
           </a:p>
         </p:txBody>
@@ -2315,7 +2726,7 @@
     </p:spTree>
     <p:extLst>
       <p:ext uri="{BB962C8B-B14F-4D97-AF65-F5344CB8AC3E}">
-        <p14:creationId xmlns:p14="http://schemas.microsoft.com/office/powerpoint/2010/main" val="1741913337"/>
+        <p14:creationId xmlns:p14="http://schemas.microsoft.com/office/powerpoint/2010/main" val="1217319407"/>
       </p:ext>
     </p:extLst>
   </p:cSld>
@@ -2343,10 +2754,10 @@
       </p:grpSpPr>
       <p:sp>
         <p:nvSpPr>
-          <p:cNvPr id="12" name="experience-title">
+          <p:cNvPr id="11" name="title">
             <a:extLst xmlns:a="http://schemas.openxmlformats.org/drawingml/2006/main">
               <a:ext uri="{FF2B5EF4-FFF2-40B4-BE49-F238E27FC236}">
-                <a16:creationId xmlns:a16="http://schemas.microsoft.com/office/drawing/2014/main" id="{E12A9ADB-89D5-4242-8703-C068E19A2B42}"/>
+                <a16:creationId xmlns:a16="http://schemas.microsoft.com/office/drawing/2014/main" id="{D4D80803-54BE-4255-9694-0F2A12A97C57}"/>
               </a:ext>
             </a:extLst>
           </p:cNvPr>
@@ -2357,8 +2768,8 @@
         </p:nvSpPr>
         <p:spPr>
           <a:xfrm xmlns:a="http://schemas.openxmlformats.org/drawingml/2006/main">
-            <a:off x="666750" y="466725"/>
-            <a:ext cx="10668000" cy="1143000"/>
+            <a:off x="666750" y="438150"/>
+            <a:ext cx="10763250" cy="1190625"/>
           </a:xfrm>
           <a:prstGeom xmlns:a="http://schemas.openxmlformats.org/drawingml/2006/main" prst="rect">
             <a:avLst/>
@@ -2375,7 +2786,7 @@
           <a:lstStyle xmlns:a="http://schemas.openxmlformats.org/drawingml/2006/main"/>
           <a:p xmlns:a="http://schemas.openxmlformats.org/drawingml/2006/main">
             <a:pPr>
-              <a:defRPr sz="3450" b="1">
+              <a:defRPr sz="3900" b="1">
                 <a:solidFill>
                   <a:srgbClr val="263F35"/>
                 </a:solidFill>
@@ -2385,7 +2796,7 @@
               </a:defRPr>
             </a:pPr>
             <a:r>
-              <a:rPr sz="3450" b="1">
+              <a:rPr sz="3900" b="1">
                 <a:solidFill>
                   <a:srgbClr val="263F35"/>
                 </a:solidFill>
@@ -2393,12 +2804,12 @@
                 <a:ea typeface="IBM Plex Sans KR"/>
                 <a:cs typeface="IBM Plex Sans KR"/>
               </a:rPr>
-              <a:t>옷장을 열던 손길이</a:t>
-            </a:r>
-          </a:p>
-          <a:p xmlns:a="http://schemas.openxmlformats.org/drawingml/2006/main">
-            <a:pPr>
-              <a:defRPr sz="3450" b="1">
+              <a:t>탐색하는 동안에도</a:t>
+            </a:r>
+          </a:p>
+          <a:p xmlns:a="http://schemas.openxmlformats.org/drawingml/2006/main">
+            <a:pPr>
+              <a:defRPr sz="3900" b="1">
                 <a:solidFill>
                   <a:srgbClr val="263F35"/>
                 </a:solidFill>
@@ -2408,7 +2819,7 @@
               </a:defRPr>
             </a:pPr>
             <a:r>
-              <a:rPr sz="3450" b="1">
+              <a:rPr sz="3900" b="1">
                 <a:solidFill>
                   <a:srgbClr val="263F35"/>
                 </a:solidFill>
@@ -2416,7 +2827,64 @@
                 <a:ea typeface="IBM Plex Sans KR"/>
                 <a:cs typeface="IBM Plex Sans KR"/>
               </a:rPr>
-              <a:t>다음 쇼핑으로 이어진다</a:t>
+              <a:t>내 물건과 선택은 이어진다</a:t>
+            </a:r>
+          </a:p>
+        </p:txBody>
+      </p:sp>
+      <p:sp>
+        <p:nvSpPr>
+          <p:cNvPr id="2" name="why">
+            <a:extLst xmlns:a="http://schemas.openxmlformats.org/drawingml/2006/main">
+              <a:ext uri="{FF2B5EF4-FFF2-40B4-BE49-F238E27FC236}">
+                <a16:creationId xmlns:a16="http://schemas.microsoft.com/office/drawing/2014/main" id="{440E342F-F418-4E37-A177-3D6742BF4734}"/>
+              </a:ext>
+            </a:extLst>
+          </p:cNvPr>
+          <p:cNvSpPr>
+            <a:spLocks xmlns:a="http://schemas.openxmlformats.org/drawingml/2006/main" noGrp="1"/>
+          </p:cNvSpPr>
+          <p:nvPr/>
+        </p:nvSpPr>
+        <p:spPr>
+          <a:xfrm xmlns:a="http://schemas.openxmlformats.org/drawingml/2006/main">
+            <a:off x="704850" y="1752600"/>
+            <a:ext cx="10572750" cy="438150"/>
+          </a:xfrm>
+          <a:prstGeom xmlns:a="http://schemas.openxmlformats.org/drawingml/2006/main" prst="rect">
+            <a:avLst/>
+          </a:prstGeom>
+          <a:noFill xmlns:a="http://schemas.openxmlformats.org/drawingml/2006/main"/>
+          <a:ln xmlns:a="http://schemas.openxmlformats.org/drawingml/2006/main" w="0">
+            <a:noFill/>
+          </a:ln>
+        </p:spPr>
+        <p:txBody>
+          <a:bodyPr xmlns:a="http://schemas.openxmlformats.org/drawingml/2006/main" wrap="square" lIns="0" tIns="0" rIns="0" bIns="0" anchor="t">
+            <a:noAutofit/>
+          </a:bodyPr>
+          <a:lstStyle xmlns:a="http://schemas.openxmlformats.org/drawingml/2006/main"/>
+          <a:p xmlns:a="http://schemas.openxmlformats.org/drawingml/2006/main">
+            <a:pPr>
+              <a:defRPr sz="2100" b="0">
+                <a:solidFill>
+                  <a:srgbClr val="667963"/>
+                </a:solidFill>
+                <a:latin typeface="IBM Plex Sans KR"/>
+                <a:ea typeface="IBM Plex Sans KR"/>
+                <a:cs typeface="IBM Plex Sans KR"/>
+              </a:defRPr>
+            </a:pPr>
+            <a:r>
+              <a:rPr sz="2100" b="0">
+                <a:solidFill>
+                  <a:srgbClr val="667963"/>
+                </a:solidFill>
+                <a:latin typeface="IBM Plex Sans KR"/>
+                <a:ea typeface="IBM Plex Sans KR"/>
+                <a:cs typeface="IBM Plex Sans KR"/>
+              </a:rPr>
+              <a:t>같은 옷을 확인하고, 적용한 착장으로 내 공간에 돌아온다</a:t>
             </a:r>
           </a:p>
         </p:txBody>
@@ -2430,13 +2898,13 @@
           <p:nvPr/>
         </p:nvPicPr>
         <p:blipFill>
-          <a:blip xmlns:r="http://schemas.openxmlformats.org/officeDocument/2006/relationships" xmlns:a="http://schemas.openxmlformats.org/drawingml/2006/main" r:embed="R99517197e7af4004"/>
+          <a:blip xmlns:r="http://schemas.openxmlformats.org/officeDocument/2006/relationships" xmlns:a="http://schemas.openxmlformats.org/drawingml/2006/main" r:embed="R291af0738e6e482a"/>
           <a:stretch xmlns:a="http://schemas.openxmlformats.org/drawingml/2006/main"/>
         </p:blipFill>
         <p:spPr>
           <a:xfrm xmlns:a="http://schemas.openxmlformats.org/drawingml/2006/main">
-            <a:off x="666750" y="2070327"/>
-            <a:ext cx="2657475" cy="2784021"/>
+            <a:off x="666750" y="2627124"/>
+            <a:ext cx="2457450" cy="2499102"/>
           </a:xfrm>
           <a:prstGeom xmlns:a="http://schemas.openxmlformats.org/drawingml/2006/main" prst="rect">
             <a:avLst/>
@@ -2452,13 +2920,13 @@
           <p:nvPr/>
         </p:nvPicPr>
         <p:blipFill>
-          <a:blip xmlns:r="http://schemas.openxmlformats.org/officeDocument/2006/relationships" xmlns:a="http://schemas.openxmlformats.org/drawingml/2006/main" r:embed="Re4f63e77c70f4d53"/>
+          <a:blip xmlns:r="http://schemas.openxmlformats.org/officeDocument/2006/relationships" xmlns:a="http://schemas.openxmlformats.org/drawingml/2006/main" r:embed="R47b5de2622324619"/>
           <a:stretch xmlns:a="http://schemas.openxmlformats.org/drawingml/2006/main"/>
         </p:blipFill>
         <p:spPr>
           <a:xfrm xmlns:a="http://schemas.openxmlformats.org/drawingml/2006/main">
-            <a:off x="3895725" y="2259648"/>
-            <a:ext cx="4143375" cy="2300603"/>
+            <a:off x="3705225" y="2287995"/>
+            <a:ext cx="4476750" cy="2901134"/>
           </a:xfrm>
           <a:prstGeom xmlns:a="http://schemas.openxmlformats.org/drawingml/2006/main" prst="rect">
             <a:avLst/>
@@ -2474,13 +2942,13 @@
           <p:nvPr/>
         </p:nvPicPr>
         <p:blipFill>
-          <a:blip xmlns:r="http://schemas.openxmlformats.org/officeDocument/2006/relationships" xmlns:a="http://schemas.openxmlformats.org/drawingml/2006/main" r:embed="Ref0e9f6c746847bd"/>
+          <a:blip xmlns:r="http://schemas.openxmlformats.org/officeDocument/2006/relationships" xmlns:a="http://schemas.openxmlformats.org/drawingml/2006/main" r:embed="R0dc808c3390b464d"/>
           <a:stretch xmlns:a="http://schemas.openxmlformats.org/drawingml/2006/main"/>
         </p:blipFill>
         <p:spPr>
           <a:xfrm xmlns:a="http://schemas.openxmlformats.org/drawingml/2006/main">
-            <a:off x="8820150" y="2070327"/>
-            <a:ext cx="2657475" cy="2784021"/>
+            <a:off x="8963025" y="2627124"/>
+            <a:ext cx="2457450" cy="2499102"/>
           </a:xfrm>
           <a:prstGeom xmlns:a="http://schemas.openxmlformats.org/drawingml/2006/main" prst="rect">
             <a:avLst/>
@@ -2489,10 +2957,10 @@
       </p:pic>
       <p:sp>
         <p:nvSpPr>
-          <p:cNvPr id="5" name="step-one-label">
+          <p:cNvPr id="6" name="a">
             <a:extLst xmlns:a="http://schemas.openxmlformats.org/drawingml/2006/main">
               <a:ext uri="{FF2B5EF4-FFF2-40B4-BE49-F238E27FC236}">
-                <a16:creationId xmlns:a16="http://schemas.microsoft.com/office/drawing/2014/main" id="{734AD5DE-5D81-43DE-84FC-72CA006A73FF}"/>
+                <a16:creationId xmlns:a16="http://schemas.microsoft.com/office/drawing/2014/main" id="{E78084A8-0265-4F58-B484-2FC34ECABC73}"/>
               </a:ext>
             </a:extLst>
           </p:cNvPr>
@@ -2503,8 +2971,8 @@
         </p:nvSpPr>
         <p:spPr>
           <a:xfrm xmlns:a="http://schemas.openxmlformats.org/drawingml/2006/main">
-            <a:off x="666750" y="5172075"/>
-            <a:ext cx="2762250" cy="409575"/>
+            <a:off x="666750" y="5391150"/>
+            <a:ext cx="2857500" cy="438150"/>
           </a:xfrm>
           <a:prstGeom xmlns:a="http://schemas.openxmlformats.org/drawingml/2006/main" prst="rect">
             <a:avLst/>
@@ -2539,17 +3007,17 @@
                 <a:ea typeface="IBM Plex Sans KR"/>
                 <a:cs typeface="IBM Plex Sans KR"/>
               </a:rPr>
-              <a:t>01   열고 둘러보기</a:t>
-            </a:r>
-          </a:p>
-        </p:txBody>
-      </p:sp>
-      <p:sp>
-        <p:nvSpPr>
-          <p:cNvPr id="6" name="step-one">
+              <a:t>보유 상품 확인</a:t>
+            </a:r>
+          </a:p>
+        </p:txBody>
+      </p:sp>
+      <p:sp>
+        <p:nvSpPr>
+          <p:cNvPr id="7" name="b">
             <a:extLst xmlns:a="http://schemas.openxmlformats.org/drawingml/2006/main">
               <a:ext uri="{FF2B5EF4-FFF2-40B4-BE49-F238E27FC236}">
-                <a16:creationId xmlns:a16="http://schemas.microsoft.com/office/drawing/2014/main" id="{0DEED128-5E15-4120-9E7B-928FF98B284E}"/>
+                <a16:creationId xmlns:a16="http://schemas.microsoft.com/office/drawing/2014/main" id="{D358EB80-78A0-46F5-A8F5-6A7C26530680}"/>
               </a:ext>
             </a:extLst>
           </p:cNvPr>
@@ -2560,8 +3028,8 @@
         </p:nvSpPr>
         <p:spPr>
           <a:xfrm xmlns:a="http://schemas.openxmlformats.org/drawingml/2006/main">
-            <a:off x="666750" y="5619750"/>
-            <a:ext cx="2762250" cy="342900"/>
+            <a:off x="3705225" y="5391150"/>
+            <a:ext cx="4572000" cy="438150"/>
           </a:xfrm>
           <a:prstGeom xmlns:a="http://schemas.openxmlformats.org/drawingml/2006/main" prst="rect">
             <a:avLst/>
@@ -2578,35 +3046,35 @@
           <a:lstStyle xmlns:a="http://schemas.openxmlformats.org/drawingml/2006/main"/>
           <a:p xmlns:a="http://schemas.openxmlformats.org/drawingml/2006/main">
             <a:pPr>
-              <a:defRPr sz="1650" b="0">
-                <a:solidFill>
-                  <a:srgbClr val="667963"/>
-                </a:solidFill>
-                <a:latin typeface="IBM Plex Sans KR"/>
-                <a:ea typeface="IBM Plex Sans KR"/>
-                <a:cs typeface="IBM Plex Sans KR"/>
-              </a:defRPr>
-            </a:pPr>
-            <a:r>
-              <a:rPr sz="1650" b="0">
-                <a:solidFill>
-                  <a:srgbClr val="667963"/>
-                </a:solidFill>
-                <a:latin typeface="IBM Plex Sans KR"/>
-                <a:ea typeface="IBM Plex Sans KR"/>
-                <a:cs typeface="IBM Plex Sans KR"/>
-              </a:rPr>
-              <a:t>생활 동작이 먼저</a:t>
-            </a:r>
-          </a:p>
-        </p:txBody>
-      </p:sp>
-      <p:sp>
-        <p:nvSpPr>
-          <p:cNvPr id="7" name="step-two-label">
+              <a:defRPr sz="1950" b="1">
+                <a:solidFill>
+                  <a:srgbClr val="263F35"/>
+                </a:solidFill>
+                <a:latin typeface="IBM Plex Sans KR"/>
+                <a:ea typeface="IBM Plex Sans KR"/>
+                <a:cs typeface="IBM Plex Sans KR"/>
+              </a:defRPr>
+            </a:pPr>
+            <a:r>
+              <a:rPr sz="1950" b="1">
+                <a:solidFill>
+                  <a:srgbClr val="263F35"/>
+                </a:solidFill>
+                <a:latin typeface="IBM Plex Sans KR"/>
+                <a:ea typeface="IBM Plex Sans KR"/>
+                <a:cs typeface="IBM Plex Sans KR"/>
+              </a:rPr>
+              <a:t>명시적으로 착장 적용</a:t>
+            </a:r>
+          </a:p>
+        </p:txBody>
+      </p:sp>
+      <p:sp>
+        <p:nvSpPr>
+          <p:cNvPr id="8" name="c">
             <a:extLst xmlns:a="http://schemas.openxmlformats.org/drawingml/2006/main">
               <a:ext uri="{FF2B5EF4-FFF2-40B4-BE49-F238E27FC236}">
-                <a16:creationId xmlns:a16="http://schemas.microsoft.com/office/drawing/2014/main" id="{CB7B3D7D-539F-4B4E-A819-8197CD7309D4}"/>
+                <a16:creationId xmlns:a16="http://schemas.microsoft.com/office/drawing/2014/main" id="{75B5ABE2-893E-4A32-962D-40A7A3D44D14}"/>
               </a:ext>
             </a:extLst>
           </p:cNvPr>
@@ -2617,8 +3085,8 @@
         </p:nvSpPr>
         <p:spPr>
           <a:xfrm xmlns:a="http://schemas.openxmlformats.org/drawingml/2006/main">
-            <a:off x="3895725" y="5172075"/>
-            <a:ext cx="4191000" cy="409575"/>
+            <a:off x="8963025" y="5391150"/>
+            <a:ext cx="2857500" cy="438150"/>
           </a:xfrm>
           <a:prstGeom xmlns:a="http://schemas.openxmlformats.org/drawingml/2006/main" prst="rect">
             <a:avLst/>
@@ -2653,17 +3121,17 @@
                 <a:ea typeface="IBM Plex Sans KR"/>
                 <a:cs typeface="IBM Plex Sans KR"/>
               </a:rPr>
-              <a:t>02   입어본 뒤 적용</a:t>
-            </a:r>
-          </a:p>
-        </p:txBody>
-      </p:sp>
-      <p:sp>
-        <p:nvSpPr>
-          <p:cNvPr id="8" name="step-two">
+              <a:t>내 공간에 유지</a:t>
+            </a:r>
+          </a:p>
+        </p:txBody>
+      </p:sp>
+      <p:sp>
+        <p:nvSpPr>
+          <p:cNvPr id="9" name="footnote">
             <a:extLst xmlns:a="http://schemas.openxmlformats.org/drawingml/2006/main">
               <a:ext uri="{FF2B5EF4-FFF2-40B4-BE49-F238E27FC236}">
-                <a16:creationId xmlns:a16="http://schemas.microsoft.com/office/drawing/2014/main" id="{BF8008F8-FCFD-4566-926F-C88037611842}"/>
+                <a16:creationId xmlns:a16="http://schemas.microsoft.com/office/drawing/2014/main" id="{F9E72D5B-439A-4754-B320-03E89ED4CC63}"/>
               </a:ext>
             </a:extLst>
           </p:cNvPr>
@@ -2674,8 +3142,8 @@
         </p:nvSpPr>
         <p:spPr>
           <a:xfrm xmlns:a="http://schemas.openxmlformats.org/drawingml/2006/main">
-            <a:off x="3895725" y="5619750"/>
-            <a:ext cx="4191000" cy="342900"/>
+            <a:off x="685800" y="6362700"/>
+            <a:ext cx="10572750" cy="228600"/>
           </a:xfrm>
           <a:prstGeom xmlns:a="http://schemas.openxmlformats.org/drawingml/2006/main" prst="rect">
             <a:avLst/>
@@ -2692,7 +3160,7 @@
           <a:lstStyle xmlns:a="http://schemas.openxmlformats.org/drawingml/2006/main"/>
           <a:p xmlns:a="http://schemas.openxmlformats.org/drawingml/2006/main">
             <a:pPr>
-              <a:defRPr sz="1650" b="0">
+              <a:defRPr sz="1275" b="0">
                 <a:solidFill>
                   <a:srgbClr val="667963"/>
                 </a:solidFill>
@@ -2702,7 +3170,7 @@
               </a:defRPr>
             </a:pPr>
             <a:r>
-              <a:rPr sz="1650" b="0">
+              <a:rPr sz="1275" b="0">
                 <a:solidFill>
                   <a:srgbClr val="667963"/>
                 </a:solidFill>
@@ -2710,17 +3178,17 @@
                 <a:ea typeface="IBM Plex Sans KR"/>
                 <a:cs typeface="IBM Plex Sans KR"/>
               </a:rPr>
-              <a:t>내 착장을 바꾸는 명시적 선택</a:t>
-            </a:r>
-          </a:p>
-        </p:txBody>
-      </p:sp>
-      <p:sp>
-        <p:nvSpPr>
-          <p:cNvPr id="9" name="step-three-label">
+              <a:t>동일 가상 고객의 연속 실행 화면. 보유 의류 적용 예시이며 신규 구매·가상 피팅을 뜻하지 않음</a:t>
+            </a:r>
+          </a:p>
+        </p:txBody>
+      </p:sp>
+      <p:sp>
+        <p:nvSpPr>
+          <p:cNvPr id="10" name="page">
             <a:extLst xmlns:a="http://schemas.openxmlformats.org/drawingml/2006/main">
               <a:ext uri="{FF2B5EF4-FFF2-40B4-BE49-F238E27FC236}">
-                <a16:creationId xmlns:a16="http://schemas.microsoft.com/office/drawing/2014/main" id="{98464D3E-E158-458E-AAB3-46EF06ADE122}"/>
+                <a16:creationId xmlns:a16="http://schemas.microsoft.com/office/drawing/2014/main" id="{A9148DFF-2FE8-4B52-A1CE-68358B710DD2}"/>
               </a:ext>
             </a:extLst>
           </p:cNvPr>
@@ -2731,8 +3199,8 @@
         </p:nvSpPr>
         <p:spPr>
           <a:xfrm xmlns:a="http://schemas.openxmlformats.org/drawingml/2006/main">
-            <a:off x="8820150" y="5172075"/>
-            <a:ext cx="2857500" cy="409575"/>
+            <a:off x="11287125" y="6353175"/>
+            <a:ext cx="381000" cy="247650"/>
           </a:xfrm>
           <a:prstGeom xmlns:a="http://schemas.openxmlformats.org/drawingml/2006/main" prst="rect">
             <a:avLst/>
@@ -2749,64 +3217,7 @@
           <a:lstStyle xmlns:a="http://schemas.openxmlformats.org/drawingml/2006/main"/>
           <a:p xmlns:a="http://schemas.openxmlformats.org/drawingml/2006/main">
             <a:pPr>
-              <a:defRPr sz="1950" b="1">
-                <a:solidFill>
-                  <a:srgbClr val="263F35"/>
-                </a:solidFill>
-                <a:latin typeface="IBM Plex Sans KR"/>
-                <a:ea typeface="IBM Plex Sans KR"/>
-                <a:cs typeface="IBM Plex Sans KR"/>
-              </a:defRPr>
-            </a:pPr>
-            <a:r>
-              <a:rPr sz="1950" b="1">
-                <a:solidFill>
-                  <a:srgbClr val="263F35"/>
-                </a:solidFill>
-                <a:latin typeface="IBM Plex Sans KR"/>
-                <a:ea typeface="IBM Plex Sans KR"/>
-                <a:cs typeface="IBM Plex Sans KR"/>
-              </a:rPr>
-              <a:t>03   같은 방으로 복귀</a:t>
-            </a:r>
-          </a:p>
-        </p:txBody>
-      </p:sp>
-      <p:sp>
-        <p:nvSpPr>
-          <p:cNvPr id="10" name="step-three">
-            <a:extLst xmlns:a="http://schemas.openxmlformats.org/drawingml/2006/main">
-              <a:ext uri="{FF2B5EF4-FFF2-40B4-BE49-F238E27FC236}">
-                <a16:creationId xmlns:a16="http://schemas.microsoft.com/office/drawing/2014/main" id="{909C27E9-C93F-46DE-926A-A7759448A9B3}"/>
-              </a:ext>
-            </a:extLst>
-          </p:cNvPr>
-          <p:cNvSpPr>
-            <a:spLocks xmlns:a="http://schemas.openxmlformats.org/drawingml/2006/main" noGrp="1"/>
-          </p:cNvSpPr>
-          <p:nvPr/>
-        </p:nvSpPr>
-        <p:spPr>
-          <a:xfrm xmlns:a="http://schemas.openxmlformats.org/drawingml/2006/main">
-            <a:off x="8820150" y="5619750"/>
-            <a:ext cx="2857500" cy="342900"/>
-          </a:xfrm>
-          <a:prstGeom xmlns:a="http://schemas.openxmlformats.org/drawingml/2006/main" prst="rect">
-            <a:avLst/>
-          </a:prstGeom>
-          <a:noFill xmlns:a="http://schemas.openxmlformats.org/drawingml/2006/main"/>
-          <a:ln xmlns:a="http://schemas.openxmlformats.org/drawingml/2006/main" w="0">
-            <a:noFill/>
-          </a:ln>
-        </p:spPr>
-        <p:txBody>
-          <a:bodyPr xmlns:a="http://schemas.openxmlformats.org/drawingml/2006/main" wrap="square" lIns="0" tIns="0" rIns="0" bIns="0" anchor="t">
-            <a:noAutofit/>
-          </a:bodyPr>
-          <a:lstStyle xmlns:a="http://schemas.openxmlformats.org/drawingml/2006/main"/>
-          <a:p xmlns:a="http://schemas.openxmlformats.org/drawingml/2006/main">
-            <a:pPr>
-              <a:defRPr sz="1650" b="0">
+              <a:defRPr sz="1350" b="0">
                 <a:solidFill>
                   <a:srgbClr val="667963"/>
                 </a:solidFill>
@@ -2816,7 +3227,7 @@
               </a:defRPr>
             </a:pPr>
             <a:r>
-              <a:rPr sz="1650" b="0">
+              <a:rPr sz="1350" b="0">
                 <a:solidFill>
                   <a:srgbClr val="667963"/>
                 </a:solidFill>
@@ -2824,64 +3235,7 @@
                 <a:ea typeface="IBM Plex Sans KR"/>
                 <a:cs typeface="IBM Plex Sans KR"/>
               </a:rPr>
-              <a:t>적용한 착장을 유지</a:t>
-            </a:r>
-          </a:p>
-        </p:txBody>
-      </p:sp>
-      <p:sp>
-        <p:nvSpPr>
-          <p:cNvPr id="11" name="flow-note">
-            <a:extLst xmlns:a="http://schemas.openxmlformats.org/drawingml/2006/main">
-              <a:ext uri="{FF2B5EF4-FFF2-40B4-BE49-F238E27FC236}">
-                <a16:creationId xmlns:a16="http://schemas.microsoft.com/office/drawing/2014/main" id="{21507FDF-2754-42E1-BFBB-35101C9EB033}"/>
-              </a:ext>
-            </a:extLst>
-          </p:cNvPr>
-          <p:cNvSpPr>
-            <a:spLocks xmlns:a="http://schemas.openxmlformats.org/drawingml/2006/main" noGrp="1"/>
-          </p:cNvSpPr>
-          <p:nvPr/>
-        </p:nvSpPr>
-        <p:spPr>
-          <a:xfrm xmlns:a="http://schemas.openxmlformats.org/drawingml/2006/main">
-            <a:off x="685800" y="6381750"/>
-            <a:ext cx="10858500" cy="285750"/>
-          </a:xfrm>
-          <a:prstGeom xmlns:a="http://schemas.openxmlformats.org/drawingml/2006/main" prst="rect">
-            <a:avLst/>
-          </a:prstGeom>
-          <a:noFill xmlns:a="http://schemas.openxmlformats.org/drawingml/2006/main"/>
-          <a:ln xmlns:a="http://schemas.openxmlformats.org/drawingml/2006/main" w="0">
-            <a:noFill/>
-          </a:ln>
-        </p:spPr>
-        <p:txBody>
-          <a:bodyPr xmlns:a="http://schemas.openxmlformats.org/drawingml/2006/main" wrap="square" lIns="0" tIns="0" rIns="0" bIns="0" anchor="t">
-            <a:noAutofit/>
-          </a:bodyPr>
-          <a:lstStyle xmlns:a="http://schemas.openxmlformats.org/drawingml/2006/main"/>
-          <a:p xmlns:a="http://schemas.openxmlformats.org/drawingml/2006/main">
-            <a:pPr>
-              <a:defRPr sz="1350" b="0">
-                <a:solidFill>
-                  <a:srgbClr val="667963"/>
-                </a:solidFill>
-                <a:latin typeface="IBM Plex Sans KR"/>
-                <a:ea typeface="IBM Plex Sans KR"/>
-                <a:cs typeface="IBM Plex Sans KR"/>
-              </a:defRPr>
-            </a:pPr>
-            <a:r>
-              <a:rPr sz="1350" b="0">
-                <a:solidFill>
-                  <a:srgbClr val="667963"/>
-                </a:solidFill>
-                <a:latin typeface="IBM Plex Sans KR"/>
-                <a:ea typeface="IBM Plex Sans KR"/>
-                <a:cs typeface="IBM Plex Sans KR"/>
-              </a:rPr>
-              <a:t>보유 상품만 착장 적용 가능. 공간의 옷은 실제 외형·가상 피팅이 아닌 예시</a:t>
+              <a:t>04</a:t>
             </a:r>
           </a:p>
         </p:txBody>
@@ -2889,7 +3243,7 @@
     </p:spTree>
     <p:extLst>
       <p:ext uri="{BB962C8B-B14F-4D97-AF65-F5344CB8AC3E}">
-        <p14:creationId xmlns:p14="http://schemas.microsoft.com/office/powerpoint/2010/main" val="1745851773"/>
+        <p14:creationId xmlns:p14="http://schemas.microsoft.com/office/powerpoint/2010/main" val="1302303006"/>
       </p:ext>
     </p:extLst>
   </p:cSld>
@@ -2917,10 +3271,10 @@
       </p:grpSpPr>
       <p:sp>
         <p:nvSpPr>
-          <p:cNvPr id="6" name="closing-headline">
+          <p:cNvPr id="7" name="brand">
             <a:extLst xmlns:a="http://schemas.openxmlformats.org/drawingml/2006/main">
               <a:ext uri="{FF2B5EF4-FFF2-40B4-BE49-F238E27FC236}">
-                <a16:creationId xmlns:a16="http://schemas.microsoft.com/office/drawing/2014/main" id="{F6976FC2-FE57-4096-9993-4ED0C4BB8B8D}"/>
+                <a16:creationId xmlns:a16="http://schemas.microsoft.com/office/drawing/2014/main" id="{5E4D965F-3B49-469E-8F0B-320614116441}"/>
               </a:ext>
             </a:extLst>
           </p:cNvPr>
@@ -2931,8 +3285,8 @@
         </p:nvSpPr>
         <p:spPr>
           <a:xfrm xmlns:a="http://schemas.openxmlformats.org/drawingml/2006/main">
-            <a:off x="666750" y="609600"/>
-            <a:ext cx="10668000" cy="1819275"/>
+            <a:off x="666750" y="447675"/>
+            <a:ext cx="5238750" cy="571500"/>
           </a:xfrm>
           <a:prstGeom xmlns:a="http://schemas.openxmlformats.org/drawingml/2006/main" prst="rect">
             <a:avLst/>
@@ -2949,7 +3303,7 @@
           <a:lstStyle xmlns:a="http://schemas.openxmlformats.org/drawingml/2006/main"/>
           <a:p xmlns:a="http://schemas.openxmlformats.org/drawingml/2006/main">
             <a:pPr>
-              <a:defRPr sz="4800" b="1">
+              <a:defRPr sz="2700" b="1">
                 <a:solidFill>
                   <a:srgbClr val="F5F3EB"/>
                 </a:solidFill>
@@ -2959,7 +3313,7 @@
               </a:defRPr>
             </a:pPr>
             <a:r>
-              <a:rPr sz="4800" b="1">
+              <a:rPr sz="2700" b="1">
                 <a:solidFill>
                   <a:srgbClr val="F5F3EB"/>
                 </a:solidFill>
@@ -2967,40 +3321,17 @@
                 <a:ea typeface="IBM Plex Sans KR"/>
                 <a:cs typeface="IBM Plex Sans KR"/>
               </a:rPr>
-              <a:t>다음 쇼핑의 출발점은</a:t>
-            </a:r>
-          </a:p>
-          <a:p xmlns:a="http://schemas.openxmlformats.org/drawingml/2006/main">
-            <a:pPr>
-              <a:defRPr sz="4800" b="1">
-                <a:solidFill>
-                  <a:srgbClr val="F5F3EB"/>
-                </a:solidFill>
-                <a:latin typeface="IBM Plex Sans KR"/>
-                <a:ea typeface="IBM Plex Sans KR"/>
-                <a:cs typeface="IBM Plex Sans KR"/>
-              </a:defRPr>
-            </a:pPr>
-            <a:r>
-              <a:rPr sz="4800" b="1">
-                <a:solidFill>
-                  <a:srgbClr val="F5F3EB"/>
-                </a:solidFill>
-                <a:latin typeface="IBM Plex Sans KR"/>
-                <a:ea typeface="IBM Plex Sans KR"/>
-                <a:cs typeface="IBM Plex Sans KR"/>
-              </a:rPr>
-              <a:t>나의 생활</a:t>
-            </a:r>
-          </a:p>
-        </p:txBody>
-      </p:sp>
-      <p:sp>
-        <p:nvSpPr>
-          <p:cNvPr id="2" name="closing-product">
+              <a:t>G:Scene</a:t>
+            </a:r>
+          </a:p>
+        </p:txBody>
+      </p:sp>
+      <p:sp>
+        <p:nvSpPr>
+          <p:cNvPr id="2" name="title">
             <a:extLst xmlns:a="http://schemas.openxmlformats.org/drawingml/2006/main">
               <a:ext uri="{FF2B5EF4-FFF2-40B4-BE49-F238E27FC236}">
-                <a16:creationId xmlns:a16="http://schemas.microsoft.com/office/drawing/2014/main" id="{5F471F64-4DCB-41F0-AB04-6A1710342F4F}"/>
+                <a16:creationId xmlns:a16="http://schemas.microsoft.com/office/drawing/2014/main" id="{DE97E888-0F29-45A7-9496-038167BE1B71}"/>
               </a:ext>
             </a:extLst>
           </p:cNvPr>
@@ -3011,8 +3342,8 @@
         </p:nvSpPr>
         <p:spPr>
           <a:xfrm xmlns:a="http://schemas.openxmlformats.org/drawingml/2006/main">
-            <a:off x="723900" y="2914650"/>
-            <a:ext cx="9906000" cy="885825"/>
+            <a:off x="666750" y="1400175"/>
+            <a:ext cx="10620375" cy="1866900"/>
           </a:xfrm>
           <a:prstGeom xmlns:a="http://schemas.openxmlformats.org/drawingml/2006/main" prst="rect">
             <a:avLst/>
@@ -3029,58 +3360,58 @@
           <a:lstStyle xmlns:a="http://schemas.openxmlformats.org/drawingml/2006/main"/>
           <a:p xmlns:a="http://schemas.openxmlformats.org/drawingml/2006/main">
             <a:pPr>
-              <a:defRPr sz="2325" b="0">
-                <a:solidFill>
-                  <a:srgbClr val="D5DCCD"/>
-                </a:solidFill>
-                <a:latin typeface="IBM Plex Sans KR"/>
-                <a:ea typeface="IBM Plex Sans KR"/>
-                <a:cs typeface="IBM Plex Sans KR"/>
-              </a:defRPr>
-            </a:pPr>
-            <a:r>
-              <a:rPr sz="2325" b="0">
-                <a:solidFill>
-                  <a:srgbClr val="D5DCCD"/>
-                </a:solidFill>
-                <a:latin typeface="IBM Plex Sans KR"/>
-                <a:ea typeface="IBM Plex Sans KR"/>
-                <a:cs typeface="IBM Plex Sans KR"/>
-              </a:rPr>
-              <a:t>기존 상품과 공급 역량을</a:t>
-            </a:r>
-          </a:p>
-          <a:p xmlns:a="http://schemas.openxmlformats.org/drawingml/2006/main">
-            <a:pPr>
-              <a:defRPr sz="2325" b="0">
-                <a:solidFill>
-                  <a:srgbClr val="D5DCCD"/>
-                </a:solidFill>
-                <a:latin typeface="IBM Plex Sans KR"/>
-                <a:ea typeface="IBM Plex Sans KR"/>
-                <a:cs typeface="IBM Plex Sans KR"/>
-              </a:defRPr>
-            </a:pPr>
-            <a:r>
-              <a:rPr sz="2325" b="0">
-                <a:solidFill>
-                  <a:srgbClr val="D5DCCD"/>
-                </a:solidFill>
-                <a:latin typeface="IBM Plex Sans KR"/>
-                <a:ea typeface="IBM Plex Sans KR"/>
-                <a:cs typeface="IBM Plex Sans KR"/>
-              </a:rPr>
-              <a:t>고객의 생활 맥락에 연결하는 시도</a:t>
-            </a:r>
-          </a:p>
-        </p:txBody>
-      </p:sp>
-      <p:sp>
-        <p:nvSpPr>
-          <p:cNvPr id="3" name="execution">
+              <a:defRPr sz="5850" b="1">
+                <a:solidFill>
+                  <a:srgbClr val="F5F3EB"/>
+                </a:solidFill>
+                <a:latin typeface="IBM Plex Sans KR"/>
+                <a:ea typeface="IBM Plex Sans KR"/>
+                <a:cs typeface="IBM Plex Sans KR"/>
+              </a:defRPr>
+            </a:pPr>
+            <a:r>
+              <a:rPr sz="5850" b="1">
+                <a:solidFill>
+                  <a:srgbClr val="F5F3EB"/>
+                </a:solidFill>
+                <a:latin typeface="IBM Plex Sans KR"/>
+                <a:ea typeface="IBM Plex Sans KR"/>
+                <a:cs typeface="IBM Plex Sans KR"/>
+              </a:rPr>
+              <a:t>나는 어떻게</a:t>
+            </a:r>
+          </a:p>
+          <a:p xmlns:a="http://schemas.openxmlformats.org/drawingml/2006/main">
+            <a:pPr>
+              <a:defRPr sz="5850" b="1">
+                <a:solidFill>
+                  <a:srgbClr val="F5F3EB"/>
+                </a:solidFill>
+                <a:latin typeface="IBM Plex Sans KR"/>
+                <a:ea typeface="IBM Plex Sans KR"/>
+                <a:cs typeface="IBM Plex Sans KR"/>
+              </a:defRPr>
+            </a:pPr>
+            <a:r>
+              <a:rPr sz="5850" b="1">
+                <a:solidFill>
+                  <a:srgbClr val="F5F3EB"/>
+                </a:solidFill>
+                <a:latin typeface="IBM Plex Sans KR"/>
+                <a:ea typeface="IBM Plex Sans KR"/>
+                <a:cs typeface="IBM Plex Sans KR"/>
+              </a:rPr>
+              <a:t>살고 싶은가</a:t>
+            </a:r>
+          </a:p>
+        </p:txBody>
+      </p:sp>
+      <p:sp>
+        <p:nvSpPr>
+          <p:cNvPr id="3" name="meaning">
             <a:extLst xmlns:a="http://schemas.openxmlformats.org/drawingml/2006/main">
               <a:ext uri="{FF2B5EF4-FFF2-40B4-BE49-F238E27FC236}">
-                <a16:creationId xmlns:a16="http://schemas.microsoft.com/office/drawing/2014/main" id="{4A906584-6C0A-4931-8B6B-C943671720C5}"/>
+                <a16:creationId xmlns:a16="http://schemas.microsoft.com/office/drawing/2014/main" id="{633DF408-C1A1-45BE-995F-03595A65F74B}"/>
               </a:ext>
             </a:extLst>
           </p:cNvPr>
@@ -3091,8 +3422,8 @@
         </p:nvSpPr>
         <p:spPr>
           <a:xfrm xmlns:a="http://schemas.openxmlformats.org/drawingml/2006/main">
-            <a:off x="723900" y="4267200"/>
-            <a:ext cx="9334500" cy="828675"/>
+            <a:off x="723900" y="3743325"/>
+            <a:ext cx="10572750" cy="923925"/>
           </a:xfrm>
           <a:prstGeom xmlns:a="http://schemas.openxmlformats.org/drawingml/2006/main" prst="rect">
             <a:avLst/>
@@ -3109,7 +3440,7 @@
           <a:lstStyle xmlns:a="http://schemas.openxmlformats.org/drawingml/2006/main"/>
           <a:p xmlns:a="http://schemas.openxmlformats.org/drawingml/2006/main">
             <a:pPr>
-              <a:defRPr sz="2025" b="0">
+              <a:defRPr sz="2550" b="0">
                 <a:solidFill>
                   <a:srgbClr val="D5DCCD"/>
                 </a:solidFill>
@@ -3119,7 +3450,7 @@
               </a:defRPr>
             </a:pPr>
             <a:r>
-              <a:rPr sz="2025" b="0">
+              <a:rPr sz="2550" b="0">
                 <a:solidFill>
                   <a:srgbClr val="D5DCCD"/>
                 </a:solidFill>
@@ -3127,12 +3458,12 @@
                 <a:ea typeface="IBM Plex Sans KR"/>
                 <a:cs typeface="IBM Plex Sans KR"/>
               </a:rPr>
-              <a:t>Agent 팀은 구현과 검토를 나눠</a:t>
-            </a:r>
-          </a:p>
-          <a:p xmlns:a="http://schemas.openxmlformats.org/drawingml/2006/main">
-            <a:pPr>
-              <a:defRPr sz="2025" b="0">
+              <a:t>GS SHOP의 상품 자산을</a:t>
+            </a:r>
+          </a:p>
+          <a:p xmlns:a="http://schemas.openxmlformats.org/drawingml/2006/main">
+            <a:pPr>
+              <a:defRPr sz="2550" b="0">
                 <a:solidFill>
                   <a:srgbClr val="D5DCCD"/>
                 </a:solidFill>
@@ -3142,7 +3473,7 @@
               </a:defRPr>
             </a:pPr>
             <a:r>
-              <a:rPr sz="2025" b="0">
+              <a:rPr sz="2550" b="0">
                 <a:solidFill>
                   <a:srgbClr val="D5DCCD"/>
                 </a:solidFill>
@@ -3150,17 +3481,17 @@
                 <a:ea typeface="IBM Plex Sans KR"/>
                 <a:cs typeface="IBM Plex Sans KR"/>
               </a:rPr>
-              <a:t>작동하는 경험을 고치고 다시 확인했다</a:t>
-            </a:r>
-          </a:p>
-        </p:txBody>
-      </p:sp>
-      <p:sp>
-        <p:nvSpPr>
-          <p:cNvPr id="4" name="closing-brand">
+              <a:t>나의 생활에서 탐색하는 커머스 입구</a:t>
+            </a:r>
+          </a:p>
+        </p:txBody>
+      </p:sp>
+      <p:sp>
+        <p:nvSpPr>
+          <p:cNvPr id="4" name="agent">
             <a:extLst xmlns:a="http://schemas.openxmlformats.org/drawingml/2006/main">
               <a:ext uri="{FF2B5EF4-FFF2-40B4-BE49-F238E27FC236}">
-                <a16:creationId xmlns:a16="http://schemas.microsoft.com/office/drawing/2014/main" id="{35E1F8A6-9462-4823-A1A8-A5DC2AC56B34}"/>
+                <a16:creationId xmlns:a16="http://schemas.microsoft.com/office/drawing/2014/main" id="{58186013-5C2E-4AB8-8B01-A4A33E1F05B3}"/>
               </a:ext>
             </a:extLst>
           </p:cNvPr>
@@ -3171,8 +3502,8 @@
         </p:nvSpPr>
         <p:spPr>
           <a:xfrm xmlns:a="http://schemas.openxmlformats.org/drawingml/2006/main">
-            <a:off x="7181850" y="5476875"/>
-            <a:ext cx="4476750" cy="866775"/>
+            <a:off x="723900" y="5248275"/>
+            <a:ext cx="10572750" cy="800100"/>
           </a:xfrm>
           <a:prstGeom xmlns:a="http://schemas.openxmlformats.org/drawingml/2006/main" prst="rect">
             <a:avLst/>
@@ -3189,35 +3520,58 @@
           <a:lstStyle xmlns:a="http://schemas.openxmlformats.org/drawingml/2006/main"/>
           <a:p xmlns:a="http://schemas.openxmlformats.org/drawingml/2006/main">
             <a:pPr>
-              <a:defRPr sz="4950" b="1">
-                <a:solidFill>
-                  <a:srgbClr val="F5F3EB"/>
-                </a:solidFill>
-                <a:latin typeface="IBM Plex Sans KR"/>
-                <a:ea typeface="IBM Plex Sans KR"/>
-                <a:cs typeface="IBM Plex Sans KR"/>
-              </a:defRPr>
-            </a:pPr>
-            <a:r>
-              <a:rPr sz="4950" b="1">
-                <a:solidFill>
-                  <a:srgbClr val="F5F3EB"/>
-                </a:solidFill>
-                <a:latin typeface="IBM Plex Sans KR"/>
-                <a:ea typeface="IBM Plex Sans KR"/>
-                <a:cs typeface="IBM Plex Sans KR"/>
-              </a:rPr>
-              <a:t>G:Scene</a:t>
-            </a:r>
-          </a:p>
-        </p:txBody>
-      </p:sp>
-      <p:sp>
-        <p:nvSpPr>
-          <p:cNvPr id="5" name="closing-disclosure">
+              <a:defRPr sz="1875" b="0">
+                <a:solidFill>
+                  <a:srgbClr val="D5DCCD"/>
+                </a:solidFill>
+                <a:latin typeface="IBM Plex Sans KR"/>
+                <a:ea typeface="IBM Plex Sans KR"/>
+                <a:cs typeface="IBM Plex Sans KR"/>
+              </a:defRPr>
+            </a:pPr>
+            <a:r>
+              <a:rPr sz="1875" b="0">
+                <a:solidFill>
+                  <a:srgbClr val="D5DCCD"/>
+                </a:solidFill>
+                <a:latin typeface="IBM Plex Sans KR"/>
+                <a:ea typeface="IBM Plex Sans KR"/>
+                <a:cs typeface="IBM Plex Sans KR"/>
+              </a:rPr>
+              <a:t>화면 검토 Agent가 서로 다르던 옷을 찾고,</a:t>
+            </a:r>
+          </a:p>
+          <a:p xmlns:a="http://schemas.openxmlformats.org/drawingml/2006/main">
+            <a:pPr>
+              <a:defRPr sz="1875" b="0">
+                <a:solidFill>
+                  <a:srgbClr val="D5DCCD"/>
+                </a:solidFill>
+                <a:latin typeface="IBM Plex Sans KR"/>
+                <a:ea typeface="IBM Plex Sans KR"/>
+                <a:cs typeface="IBM Plex Sans KR"/>
+              </a:defRPr>
+            </a:pPr>
+            <a:r>
+              <a:rPr sz="1875" b="0">
+                <a:solidFill>
+                  <a:srgbClr val="D5DCCD"/>
+                </a:solidFill>
+                <a:latin typeface="IBM Plex Sans KR"/>
+                <a:ea typeface="IBM Plex Sans KR"/>
+                <a:cs typeface="IBM Plex Sans KR"/>
+              </a:rPr>
+              <a:t>Builder가 같은 상품 표현으로 고쳐 다시 확인했다</a:t>
+            </a:r>
+          </a:p>
+        </p:txBody>
+      </p:sp>
+      <p:sp>
+        <p:nvSpPr>
+          <p:cNvPr id="5" name="footnote">
             <a:extLst xmlns:a="http://schemas.openxmlformats.org/drawingml/2006/main">
               <a:ext uri="{FF2B5EF4-FFF2-40B4-BE49-F238E27FC236}">
-                <a16:creationId xmlns:a16="http://schemas.microsoft.com/office/drawing/2014/main" id="{B558CBDF-B1DA-4E26-B1EF-07CAD4805D8C}"/>
+                <a16:creationId xmlns:a16="http://schemas.microsoft.com/office/drawing/2014/main" id="{60AAF9B7-2DE0-4181-9C86-5C4C4CF5C56C}"/>
               </a:ext>
             </a:extLst>
           </p:cNvPr>
@@ -3228,8 +3582,8 @@
         </p:nvSpPr>
         <p:spPr>
           <a:xfrm xmlns:a="http://schemas.openxmlformats.org/drawingml/2006/main">
-            <a:off x="723900" y="6267450"/>
-            <a:ext cx="10572750" cy="304800"/>
+            <a:off x="685800" y="6362700"/>
+            <a:ext cx="10572750" cy="228600"/>
           </a:xfrm>
           <a:prstGeom xmlns:a="http://schemas.openxmlformats.org/drawingml/2006/main" prst="rect">
             <a:avLst/>
@@ -3246,9 +3600,66 @@
           <a:lstStyle xmlns:a="http://schemas.openxmlformats.org/drawingml/2006/main"/>
           <a:p xmlns:a="http://schemas.openxmlformats.org/drawingml/2006/main">
             <a:pPr>
+              <a:defRPr sz="1275" b="0">
+                <a:solidFill>
+                  <a:srgbClr val="AEBDA5"/>
+                </a:solidFill>
+                <a:latin typeface="IBM Plex Sans KR"/>
+                <a:ea typeface="IBM Plex Sans KR"/>
+                <a:cs typeface="IBM Plex Sans KR"/>
+              </a:defRPr>
+            </a:pPr>
+            <a:r>
+              <a:rPr sz="1275" b="0">
+                <a:solidFill>
+                  <a:srgbClr val="AEBDA5"/>
+                </a:solidFill>
+                <a:latin typeface="IBM Plex Sans KR"/>
+                <a:ea typeface="IBM Plex Sans KR"/>
+                <a:cs typeface="IBM Plex Sans KR"/>
+              </a:rPr>
+              <a:t>다음 검증: 고객이 상품을 자기 생활과 연결하기 쉬워졌는가. 고객 효과·전환 성과는 미검증</a:t>
+            </a:r>
+          </a:p>
+        </p:txBody>
+      </p:sp>
+      <p:sp>
+        <p:nvSpPr>
+          <p:cNvPr id="6" name="page">
+            <a:extLst xmlns:a="http://schemas.openxmlformats.org/drawingml/2006/main">
+              <a:ext uri="{FF2B5EF4-FFF2-40B4-BE49-F238E27FC236}">
+                <a16:creationId xmlns:a16="http://schemas.microsoft.com/office/drawing/2014/main" id="{4DC18A6B-7ED5-433F-9126-1F2D787B6689}"/>
+              </a:ext>
+            </a:extLst>
+          </p:cNvPr>
+          <p:cNvSpPr>
+            <a:spLocks xmlns:a="http://schemas.openxmlformats.org/drawingml/2006/main" noGrp="1"/>
+          </p:cNvSpPr>
+          <p:nvPr/>
+        </p:nvSpPr>
+        <p:spPr>
+          <a:xfrm xmlns:a="http://schemas.openxmlformats.org/drawingml/2006/main">
+            <a:off x="11287125" y="6353175"/>
+            <a:ext cx="381000" cy="247650"/>
+          </a:xfrm>
+          <a:prstGeom xmlns:a="http://schemas.openxmlformats.org/drawingml/2006/main" prst="rect">
+            <a:avLst/>
+          </a:prstGeom>
+          <a:noFill xmlns:a="http://schemas.openxmlformats.org/drawingml/2006/main"/>
+          <a:ln xmlns:a="http://schemas.openxmlformats.org/drawingml/2006/main" w="0">
+            <a:noFill/>
+          </a:ln>
+        </p:spPr>
+        <p:txBody>
+          <a:bodyPr xmlns:a="http://schemas.openxmlformats.org/drawingml/2006/main" wrap="square" lIns="0" tIns="0" rIns="0" bIns="0" anchor="t">
+            <a:noAutofit/>
+          </a:bodyPr>
+          <a:lstStyle xmlns:a="http://schemas.openxmlformats.org/drawingml/2006/main"/>
+          <a:p xmlns:a="http://schemas.openxmlformats.org/drawingml/2006/main">
+            <a:pPr>
               <a:defRPr sz="1350" b="0">
                 <a:solidFill>
-                  <a:srgbClr val="94A687"/>
+                  <a:srgbClr val="AEBDA5"/>
                 </a:solidFill>
                 <a:latin typeface="IBM Plex Sans KR"/>
                 <a:ea typeface="IBM Plex Sans KR"/>
@@ -3258,13 +3669,13 @@
             <a:r>
               <a:rPr sz="1350" b="0">
                 <a:solidFill>
-                  <a:srgbClr val="94A687"/>
-                </a:solidFill>
-                <a:latin typeface="IBM Plex Sans KR"/>
-                <a:ea typeface="IBM Plex Sans KR"/>
-                <a:cs typeface="IBM Plex Sans KR"/>
-              </a:rPr>
-              <a:t>구현한 prototype. 고객 효과와 전환 성과는 검증이 필요하다</a:t>
+                  <a:srgbClr val="AEBDA5"/>
+                </a:solidFill>
+                <a:latin typeface="IBM Plex Sans KR"/>
+                <a:ea typeface="IBM Plex Sans KR"/>
+                <a:cs typeface="IBM Plex Sans KR"/>
+              </a:rPr>
+              <a:t>05</a:t>
             </a:r>
           </a:p>
         </p:txBody>
@@ -3272,7 +3683,7 @@
     </p:spTree>
     <p:extLst>
       <p:ext uri="{BB962C8B-B14F-4D97-AF65-F5344CB8AC3E}">
-        <p14:creationId xmlns:p14="http://schemas.microsoft.com/office/powerpoint/2010/main" val="1425269941"/>
+        <p14:creationId xmlns:p14="http://schemas.microsoft.com/office/powerpoint/2010/main" val="1675357132"/>
       </p:ext>
     </p:extLst>
   </p:cSld>

</xml_diff>